<commit_message>
Corregido desbordamiento de las cajas de leyendas (add_caption) en diapositivas 5, 8, 12, 13, 16, 17, 19 y 30
</commit_message>
<xml_diff>
--- a/output/Presentacion_Final_ELI556_Atacama_POA_Tarea2_revisado.pptx
+++ b/output/Presentacion_Final_ELI556_Atacama_POA_Tarea2_revisado.pptx
@@ -4558,8 +4558,8 @@
         </p:nvSpPr>
         <p:spPr>
           <a:xfrm>
-            <a:off x="365760" y="5349240"/>
-            <a:ext cx="11460175" cy="914400"/>
+            <a:off x="365760" y="5257800"/>
+            <a:ext cx="11460175" cy="1097280"/>
           </a:xfrm>
           <a:prstGeom prst="rect">
             <a:avLst/>
@@ -4603,8 +4603,8 @@
         </p:nvSpPr>
         <p:spPr>
           <a:xfrm>
-            <a:off x="548640" y="5422392"/>
-            <a:ext cx="11094415" cy="768096"/>
+            <a:off x="548640" y="5294376"/>
+            <a:ext cx="11094415" cy="1024127"/>
           </a:xfrm>
           <a:prstGeom prst="rect">
             <a:avLst/>
@@ -4612,7 +4612,7 @@
           <a:noFill/>
         </p:spPr>
         <p:txBody>
-          <a:bodyPr wrap="square">
+          <a:bodyPr wrap="square" lIns="0" rIns="0" tIns="0" bIns="0">
             <a:spAutoFit/>
           </a:bodyPr>
           <a:lstStyle/>
@@ -4880,8 +4880,8 @@
         </p:nvSpPr>
         <p:spPr>
           <a:xfrm>
-            <a:off x="365760" y="5303520"/>
-            <a:ext cx="11460175" cy="1097280"/>
+            <a:off x="365760" y="5212080"/>
+            <a:ext cx="11460175" cy="1234440"/>
           </a:xfrm>
           <a:prstGeom prst="rect">
             <a:avLst/>
@@ -4925,8 +4925,8 @@
         </p:nvSpPr>
         <p:spPr>
           <a:xfrm>
-            <a:off x="548640" y="5376672"/>
-            <a:ext cx="11094415" cy="950976"/>
+            <a:off x="548640" y="5248656"/>
+            <a:ext cx="11094415" cy="1161288"/>
           </a:xfrm>
           <a:prstGeom prst="rect">
             <a:avLst/>
@@ -4934,7 +4934,7 @@
           <a:noFill/>
         </p:spPr>
         <p:txBody>
-          <a:bodyPr wrap="square">
+          <a:bodyPr wrap="square" lIns="0" rIns="0" tIns="0" bIns="0">
             <a:spAutoFit/>
           </a:bodyPr>
           <a:lstStyle/>
@@ -6386,8 +6386,8 @@
         </p:nvSpPr>
         <p:spPr>
           <a:xfrm>
-            <a:off x="365760" y="5303520"/>
-            <a:ext cx="11460175" cy="1097280"/>
+            <a:off x="365760" y="5212080"/>
+            <a:ext cx="11460175" cy="1234440"/>
           </a:xfrm>
           <a:prstGeom prst="rect">
             <a:avLst/>
@@ -6431,8 +6431,8 @@
         </p:nvSpPr>
         <p:spPr>
           <a:xfrm>
-            <a:off x="548640" y="5376672"/>
-            <a:ext cx="11094415" cy="950976"/>
+            <a:off x="548640" y="5248656"/>
+            <a:ext cx="11094415" cy="1161288"/>
           </a:xfrm>
           <a:prstGeom prst="rect">
             <a:avLst/>
@@ -6440,7 +6440,7 @@
           <a:noFill/>
         </p:spPr>
         <p:txBody>
-          <a:bodyPr wrap="square">
+          <a:bodyPr wrap="square" lIns="0" rIns="0" tIns="0" bIns="0">
             <a:spAutoFit/>
           </a:bodyPr>
           <a:lstStyle/>
@@ -6692,8 +6692,8 @@
         </p:nvSpPr>
         <p:spPr>
           <a:xfrm>
-            <a:off x="365760" y="5303520"/>
-            <a:ext cx="11460175" cy="1097280"/>
+            <a:off x="365760" y="5212080"/>
+            <a:ext cx="11460175" cy="1234440"/>
           </a:xfrm>
           <a:prstGeom prst="rect">
             <a:avLst/>
@@ -6737,8 +6737,8 @@
         </p:nvSpPr>
         <p:spPr>
           <a:xfrm>
-            <a:off x="548640" y="5376672"/>
-            <a:ext cx="11094415" cy="950976"/>
+            <a:off x="548640" y="5248656"/>
+            <a:ext cx="11094415" cy="1161288"/>
           </a:xfrm>
           <a:prstGeom prst="rect">
             <a:avLst/>
@@ -6746,7 +6746,7 @@
           <a:noFill/>
         </p:spPr>
         <p:txBody>
-          <a:bodyPr wrap="square">
+          <a:bodyPr wrap="square" lIns="0" rIns="0" tIns="0" bIns="0">
             <a:spAutoFit/>
           </a:bodyPr>
           <a:lstStyle/>
@@ -8571,8 +8571,8 @@
         </p:nvSpPr>
         <p:spPr>
           <a:xfrm>
-            <a:off x="365760" y="5303520"/>
-            <a:ext cx="11460175" cy="1097280"/>
+            <a:off x="365760" y="5212080"/>
+            <a:ext cx="11460175" cy="1234440"/>
           </a:xfrm>
           <a:prstGeom prst="rect">
             <a:avLst/>
@@ -8616,8 +8616,8 @@
         </p:nvSpPr>
         <p:spPr>
           <a:xfrm>
-            <a:off x="548640" y="5376672"/>
-            <a:ext cx="11094415" cy="950976"/>
+            <a:off x="548640" y="5248656"/>
+            <a:ext cx="11094415" cy="1161288"/>
           </a:xfrm>
           <a:prstGeom prst="rect">
             <a:avLst/>
@@ -8625,7 +8625,7 @@
           <a:noFill/>
         </p:spPr>
         <p:txBody>
-          <a:bodyPr wrap="square">
+          <a:bodyPr wrap="square" lIns="0" rIns="0" tIns="0" bIns="0">
             <a:spAutoFit/>
           </a:bodyPr>
           <a:lstStyle/>
@@ -19470,8 +19470,8 @@
         </p:nvSpPr>
         <p:spPr>
           <a:xfrm>
-            <a:off x="365760" y="5532120"/>
-            <a:ext cx="11460175" cy="868680"/>
+            <a:off x="365760" y="5440680"/>
+            <a:ext cx="11460175" cy="1005840"/>
           </a:xfrm>
           <a:prstGeom prst="rect">
             <a:avLst/>
@@ -19515,8 +19515,8 @@
         </p:nvSpPr>
         <p:spPr>
           <a:xfrm>
-            <a:off x="548640" y="5605272"/>
-            <a:ext cx="11094415" cy="722375"/>
+            <a:off x="548640" y="5477256"/>
+            <a:ext cx="11094415" cy="932688"/>
           </a:xfrm>
           <a:prstGeom prst="rect">
             <a:avLst/>
@@ -19524,7 +19524,7 @@
           <a:noFill/>
         </p:spPr>
         <p:txBody>
-          <a:bodyPr wrap="square">
+          <a:bodyPr wrap="square" lIns="0" rIns="0" tIns="0" bIns="0">
             <a:spAutoFit/>
           </a:bodyPr>
           <a:lstStyle/>
@@ -26601,8 +26601,8 @@
         </p:nvSpPr>
         <p:spPr>
           <a:xfrm>
-            <a:off x="365760" y="5349240"/>
-            <a:ext cx="11460175" cy="1051560"/>
+            <a:off x="365760" y="5257800"/>
+            <a:ext cx="11460175" cy="1188720"/>
           </a:xfrm>
           <a:prstGeom prst="rect">
             <a:avLst/>
@@ -26646,8 +26646,8 @@
         </p:nvSpPr>
         <p:spPr>
           <a:xfrm>
-            <a:off x="548640" y="5422392"/>
-            <a:ext cx="11094415" cy="905255"/>
+            <a:off x="548640" y="5294376"/>
+            <a:ext cx="11094415" cy="1115568"/>
           </a:xfrm>
           <a:prstGeom prst="rect">
             <a:avLst/>
@@ -26655,7 +26655,7 @@
           <a:noFill/>
         </p:spPr>
         <p:txBody>
-          <a:bodyPr wrap="square">
+          <a:bodyPr wrap="square" lIns="0" rIns="0" tIns="0" bIns="0">
             <a:spAutoFit/>
           </a:bodyPr>
           <a:lstStyle/>
@@ -28923,8 +28923,8 @@
         </p:nvSpPr>
         <p:spPr>
           <a:xfrm>
-            <a:off x="365760" y="5349240"/>
-            <a:ext cx="11460175" cy="1051560"/>
+            <a:off x="365760" y="5257800"/>
+            <a:ext cx="11460175" cy="1188720"/>
           </a:xfrm>
           <a:prstGeom prst="rect">
             <a:avLst/>
@@ -28968,8 +28968,8 @@
         </p:nvSpPr>
         <p:spPr>
           <a:xfrm>
-            <a:off x="548640" y="5422392"/>
-            <a:ext cx="11094415" cy="905255"/>
+            <a:off x="548640" y="5294376"/>
+            <a:ext cx="11094415" cy="1115568"/>
           </a:xfrm>
           <a:prstGeom prst="rect">
             <a:avLst/>
@@ -28977,7 +28977,7 @@
           <a:noFill/>
         </p:spPr>
         <p:txBody>
-          <a:bodyPr wrap="square">
+          <a:bodyPr wrap="square" lIns="0" rIns="0" tIns="0" bIns="0">
             <a:spAutoFit/>
           </a:bodyPr>
           <a:lstStyle/>

</xml_diff>

<commit_message>
Ajuste del diagrama CSV: subida de la imagen y aumento de fuentes en las cajas
</commit_message>
<xml_diff>
--- a/output/Presentacion_Final_ELI556_Atacama_POA_Tarea2_revisado.pptx
+++ b/output/Presentacion_Final_ELI556_Atacama_POA_Tarea2_revisado.pptx
@@ -28907,7 +28907,7 @@
         </p:blipFill>
         <p:spPr>
           <a:xfrm>
-            <a:off x="380847" y="1188720"/>
+            <a:off x="380847" y="1097280"/>
             <a:ext cx="11430000" cy="4019340"/>
           </a:xfrm>
           <a:prstGeom prst="rect">
@@ -28923,8 +28923,8 @@
         </p:nvSpPr>
         <p:spPr>
           <a:xfrm>
-            <a:off x="365760" y="5257800"/>
-            <a:ext cx="11460175" cy="1188720"/>
+            <a:off x="365760" y="5212080"/>
+            <a:ext cx="11460175" cy="1234440"/>
           </a:xfrm>
           <a:prstGeom prst="rect">
             <a:avLst/>
@@ -28968,8 +28968,8 @@
         </p:nvSpPr>
         <p:spPr>
           <a:xfrm>
-            <a:off x="548640" y="5294376"/>
-            <a:ext cx="11094415" cy="1115568"/>
+            <a:off x="548640" y="5248656"/>
+            <a:ext cx="11094415" cy="1161288"/>
           </a:xfrm>
           <a:prstGeom prst="rect">
             <a:avLst/>

</xml_diff>

<commit_message>
Rediseño de la diapositiva 9: incorporación de nuevo diagrama de ingesta y limpieza
</commit_message>
<xml_diff>
--- a/output/Presentacion_Final_ELI556_Atacama_POA_Tarea2_revisado.pptx
+++ b/output/Presentacion_Final_ELI556_Atacama_POA_Tarea2_revisado.pptx
@@ -29197,16 +29197,40 @@
           </a:p>
         </p:txBody>
       </p:sp>
-      <p:sp>
-        <p:nvSpPr>
-          <p:cNvPr id="5" name="Rectangle 4"/>
+      <p:pic>
+        <p:nvPicPr>
+          <p:cNvPr id="5" name="Picture 4" descr="ingesta_limpieza.png"/>
+          <p:cNvPicPr>
+            <a:picLocks noChangeAspect="1"/>
+          </p:cNvPicPr>
+          <p:nvPr/>
+        </p:nvPicPr>
+        <p:blipFill>
+          <a:blip r:embed="rId2"/>
+          <a:stretch>
+            <a:fillRect/>
+          </a:stretch>
+        </p:blipFill>
+        <p:spPr>
+          <a:xfrm>
+            <a:off x="380847" y="1097280"/>
+            <a:ext cx="11430000" cy="4019340"/>
+          </a:xfrm>
+          <a:prstGeom prst="rect">
+            <a:avLst/>
+          </a:prstGeom>
+        </p:spPr>
+      </p:pic>
+      <p:sp>
+        <p:nvSpPr>
+          <p:cNvPr id="6" name="Rectangle 5"/>
           <p:cNvSpPr/>
           <p:nvPr/>
         </p:nvSpPr>
         <p:spPr>
           <a:xfrm>
-            <a:off x="365760" y="1188720"/>
-            <a:ext cx="5592927" cy="4983480"/>
+            <a:off x="365760" y="5212080"/>
+            <a:ext cx="11460175" cy="1234440"/>
           </a:xfrm>
           <a:prstGeom prst="rect">
             <a:avLst/>
@@ -29216,7 +29240,7 @@
           </a:solidFill>
           <a:ln w="12700">
             <a:solidFill>
-              <a:srgbClr val="FF5E3A"/>
+              <a:srgbClr val="F1C40F"/>
             </a:solidFill>
           </a:ln>
         </p:spPr>
@@ -29244,57 +29268,14 @@
       </p:sp>
       <p:sp>
         <p:nvSpPr>
-          <p:cNvPr id="6" name="Rectangle 5"/>
-          <p:cNvSpPr/>
-          <p:nvPr/>
-        </p:nvSpPr>
-        <p:spPr>
-          <a:xfrm>
-            <a:off x="365760" y="1188720"/>
-            <a:ext cx="73152" cy="4983480"/>
-          </a:xfrm>
-          <a:prstGeom prst="rect">
-            <a:avLst/>
-          </a:prstGeom>
-          <a:solidFill>
-            <a:srgbClr val="FF5E3A"/>
-          </a:solidFill>
-          <a:ln>
-            <a:noFill/>
-          </a:ln>
-        </p:spPr>
-        <p:style>
-          <a:lnRef idx="1">
-            <a:schemeClr val="accent1"/>
-          </a:lnRef>
-          <a:fillRef idx="3">
-            <a:schemeClr val="accent1"/>
-          </a:fillRef>
-          <a:effectRef idx="2">
-            <a:schemeClr val="accent1"/>
-          </a:effectRef>
-          <a:fontRef idx="minor">
-            <a:schemeClr val="lt1"/>
-          </a:fontRef>
-        </p:style>
-        <p:txBody>
-          <a:bodyPr rtlCol="0" anchor="ctr"/>
-          <a:lstStyle/>
-          <a:p>
-            <a:pPr algn="ctr"/>
-          </a:p>
-        </p:txBody>
-      </p:sp>
-      <p:sp>
-        <p:nvSpPr>
           <p:cNvPr id="7" name="TextBox 6"/>
           <p:cNvSpPr txBox="1"/>
           <p:nvPr/>
         </p:nvSpPr>
         <p:spPr>
           <a:xfrm>
-            <a:off x="530352" y="1280160"/>
-            <a:ext cx="5318607" cy="411480"/>
+            <a:off x="548640" y="5248656"/>
+            <a:ext cx="11094415" cy="1161288"/>
           </a:xfrm>
           <a:prstGeom prst="rect">
             <a:avLst/>
@@ -29302,130 +29283,34 @@
           <a:noFill/>
         </p:spPr>
         <p:txBody>
-          <a:bodyPr wrap="none">
+          <a:bodyPr wrap="square" lIns="0" rIns="0" tIns="0" bIns="0">
             <a:spAutoFit/>
           </a:bodyPr>
           <a:lstStyle/>
           <a:p>
-            <a:pPr algn="l"/>
-            <a:r>
-              <a:rPr sz="1800" b="1">
-                <a:solidFill>
-                  <a:srgbClr val="F1C40F"/>
-                </a:solidFill>
-              </a:rPr>
-              <a:t>El Desafío: archivos irregulares de ~110 MB</a:t>
-            </a:r>
-          </a:p>
-        </p:txBody>
-      </p:sp>
-      <p:sp>
-        <p:nvSpPr>
-          <p:cNvPr id="8" name="TextBox 7"/>
-          <p:cNvSpPr txBox="1"/>
-          <p:nvPr/>
-        </p:nvSpPr>
-        <p:spPr>
-          <a:xfrm>
-            <a:off x="566928" y="1828800"/>
-            <a:ext cx="5190591" cy="4178808"/>
-          </a:xfrm>
-          <a:prstGeom prst="rect">
-            <a:avLst/>
-          </a:prstGeom>
-          <a:noFill/>
-        </p:spPr>
-        <p:txBody>
-          <a:bodyPr wrap="square">
-            <a:spAutoFit/>
-          </a:bodyPr>
-          <a:lstStyle/>
-          <a:p>
             <a:pPr algn="l">
               <a:lnSpc>
-                <a:spcPct val="110000"/>
+                <a:spcPct val="108000"/>
               </a:lnSpc>
             </a:pPr>
             <a:r>
-              <a:rPr sz="1700">
-                <a:solidFill>
-                  <a:srgbClr val="FBFCFD"/>
-                </a:solidFill>
-              </a:rPr>
-              <a:t>• </a:t>
-            </a:r>
-            <a:r>
-              <a:rPr sz="1700" b="1">
-                <a:solidFill>
-                  <a:srgbClr val="FBFCFD"/>
-                </a:solidFill>
-              </a:rPr>
-              <a:t>Naturaleza de los datos:</a:t>
-            </a:r>
-            <a:r>
-              <a:rPr sz="1700">
-                <a:solidFill>
-                  <a:srgbClr val="FBFCFD"/>
-                </a:solidFill>
-              </a:rPr>
-              <a:t> cada fila contiene 43 columnas fijas + </a:t>
-            </a:r>
-            <a:r>
-              <a:rPr sz="1700" b="1">
-                <a:solidFill>
-                  <a:srgbClr val="FBFCFD"/>
-                </a:solidFill>
-              </a:rPr>
-              <a:t>n pares (I, V) crudos</a:t>
-            </a:r>
-            <a:r>
-              <a:rPr sz="1700">
-                <a:solidFill>
-                  <a:srgbClr val="FBFCFD"/>
-                </a:solidFill>
-              </a:rPr>
-              <a:t> de la curva trazada (n ≈ 180–380) → filas de longitud variable.</a:t>
-            </a:r>
-          </a:p>
-          <a:p>
-            <a:pPr algn="l">
-              <a:lnSpc>
-                <a:spcPct val="110000"/>
-              </a:lnSpc>
-            </a:pPr>
-          </a:p>
-          <a:p>
-            <a:pPr algn="l">
-              <a:lnSpc>
-                <a:spcPct val="110000"/>
-              </a:lnSpc>
-            </a:pPr>
-            <a:r>
-              <a:rPr sz="1700">
-                <a:solidFill>
-                  <a:srgbClr val="FBFCFD"/>
-                </a:solidFill>
-              </a:rPr>
-              <a:t>• </a:t>
-            </a:r>
-            <a:r>
-              <a:rPr sz="1700" b="1">
-                <a:solidFill>
-                  <a:srgbClr val="FBFCFD"/>
-                </a:solidFill>
-              </a:rPr>
-              <a:t>Falla del método estándar:</a:t>
-            </a:r>
-            <a:r>
-              <a:rPr sz="1700">
-                <a:solidFill>
-                  <a:srgbClr val="FBFCFD"/>
-                </a:solidFill>
-              </a:rPr>
-              <a:t> </a:t>
-            </a:r>
-            <a:r>
-              <a:rPr sz="1600">
+              <a:rPr sz="1750" b="1">
+                <a:solidFill>
+                  <a:srgbClr val="FBFCFD"/>
+                </a:solidFill>
+              </a:rPr>
+              <a:t>Proceso de ingesta y depuración:</a:t>
+            </a:r>
+            <a:r>
+              <a:rPr sz="1750">
+                <a:solidFill>
+                  <a:srgbClr val="FBFCFD"/>
+                </a:solidFill>
+              </a:rPr>
+              <a:t> El gran volumen de datos (~110 MB por archivo) y el ancho de fila variable debido a la cola de curvas I-V impiden el uso de métodos convencionales como </a:t>
+            </a:r>
+            <a:r>
+              <a:rPr sz="1650">
                 <a:solidFill>
                   <a:srgbClr val="7FDBFF"/>
                 </a:solidFill>
@@ -29434,431 +29319,53 @@
               <a:t>pandas.read_csv</a:t>
             </a:r>
             <a:r>
-              <a:rPr sz="1700">
-                <a:solidFill>
-                  <a:srgbClr val="FBFCFD"/>
-                </a:solidFill>
-              </a:rPr>
-              <a:t> no tolera el ancho variable (infiere mal el esquema) y carga ~110 MB por módulo a memoria innecesariamente.</a:t>
-            </a:r>
-          </a:p>
-          <a:p>
-            <a:pPr algn="l">
-              <a:lnSpc>
-                <a:spcPct val="110000"/>
-              </a:lnSpc>
-            </a:pPr>
-          </a:p>
-          <a:p>
-            <a:pPr algn="l">
-              <a:lnSpc>
-                <a:spcPct val="110000"/>
-              </a:lnSpc>
-            </a:pPr>
-            <a:r>
-              <a:rPr sz="1700">
-                <a:solidFill>
-                  <a:srgbClr val="FBFCFD"/>
-                </a:solidFill>
-              </a:rPr>
-              <a:t>• </a:t>
-            </a:r>
-            <a:r>
-              <a:rPr sz="1700" b="1">
-                <a:solidFill>
-                  <a:srgbClr val="FBFCFD"/>
-                </a:solidFill>
-              </a:rPr>
-              <a:t>Datos centinela:</a:t>
-            </a:r>
-            <a:r>
-              <a:rPr sz="1700">
-                <a:solidFill>
-                  <a:srgbClr val="FBFCFD"/>
-                </a:solidFill>
-              </a:rPr>
-              <a:t> los faltantes vienen codificados como </a:t>
-            </a:r>
-            <a:r>
-              <a:rPr sz="1700" b="1">
-                <a:solidFill>
-                  <a:srgbClr val="FBFCFD"/>
-                </a:solidFill>
-              </a:rPr>
-              <a:t>−9999</a:t>
-            </a:r>
-            <a:r>
-              <a:rPr sz="1700">
-                <a:solidFill>
-                  <a:srgbClr val="FBFCFD"/>
-                </a:solidFill>
-              </a:rPr>
-              <a:t>, que contaminan promedios y regresiones si no se neutralizan.</a:t>
-            </a:r>
-          </a:p>
-        </p:txBody>
-      </p:sp>
-      <p:sp>
-        <p:nvSpPr>
-          <p:cNvPr id="9" name="Rectangle 8"/>
-          <p:cNvSpPr/>
-          <p:nvPr/>
-        </p:nvSpPr>
-        <p:spPr>
-          <a:xfrm>
-            <a:off x="6233007" y="1188720"/>
-            <a:ext cx="5592927" cy="4983480"/>
-          </a:xfrm>
-          <a:prstGeom prst="rect">
-            <a:avLst/>
-          </a:prstGeom>
-          <a:solidFill>
-            <a:srgbClr val="1F2833"/>
-          </a:solidFill>
-          <a:ln w="12700">
-            <a:solidFill>
-              <a:srgbClr val="00D2FF"/>
-            </a:solidFill>
-          </a:ln>
-        </p:spPr>
-        <p:style>
-          <a:lnRef idx="1">
-            <a:schemeClr val="accent1"/>
-          </a:lnRef>
-          <a:fillRef idx="3">
-            <a:schemeClr val="accent1"/>
-          </a:fillRef>
-          <a:effectRef idx="2">
-            <a:schemeClr val="accent1"/>
-          </a:effectRef>
-          <a:fontRef idx="minor">
-            <a:schemeClr val="lt1"/>
-          </a:fontRef>
-        </p:style>
-        <p:txBody>
-          <a:bodyPr rtlCol="0" anchor="ctr"/>
-          <a:lstStyle/>
-          <a:p>
-            <a:pPr algn="ctr"/>
-          </a:p>
-        </p:txBody>
-      </p:sp>
-      <p:sp>
-        <p:nvSpPr>
-          <p:cNvPr id="10" name="Rectangle 9"/>
-          <p:cNvSpPr/>
-          <p:nvPr/>
-        </p:nvSpPr>
-        <p:spPr>
-          <a:xfrm>
-            <a:off x="6233007" y="1188720"/>
-            <a:ext cx="73152" cy="4983480"/>
-          </a:xfrm>
-          <a:prstGeom prst="rect">
-            <a:avLst/>
-          </a:prstGeom>
-          <a:solidFill>
-            <a:srgbClr val="00D2FF"/>
-          </a:solidFill>
-          <a:ln>
-            <a:noFill/>
-          </a:ln>
-        </p:spPr>
-        <p:style>
-          <a:lnRef idx="1">
-            <a:schemeClr val="accent1"/>
-          </a:lnRef>
-          <a:fillRef idx="3">
-            <a:schemeClr val="accent1"/>
-          </a:fillRef>
-          <a:effectRef idx="2">
-            <a:schemeClr val="accent1"/>
-          </a:effectRef>
-          <a:fontRef idx="minor">
-            <a:schemeClr val="lt1"/>
-          </a:fontRef>
-        </p:style>
-        <p:txBody>
-          <a:bodyPr rtlCol="0" anchor="ctr"/>
-          <a:lstStyle/>
-          <a:p>
-            <a:pPr algn="ctr"/>
-          </a:p>
-        </p:txBody>
-      </p:sp>
-      <p:sp>
-        <p:nvSpPr>
-          <p:cNvPr id="11" name="TextBox 10"/>
-          <p:cNvSpPr txBox="1"/>
-          <p:nvPr/>
-        </p:nvSpPr>
-        <p:spPr>
-          <a:xfrm>
-            <a:off x="6397599" y="1280160"/>
-            <a:ext cx="5318607" cy="411480"/>
-          </a:xfrm>
-          <a:prstGeom prst="rect">
-            <a:avLst/>
-          </a:prstGeom>
-          <a:noFill/>
-        </p:spPr>
-        <p:txBody>
-          <a:bodyPr wrap="none">
-            <a:spAutoFit/>
-          </a:bodyPr>
-          <a:lstStyle/>
-          <a:p>
-            <a:pPr algn="l"/>
-            <a:r>
-              <a:rPr sz="1800" b="1">
-                <a:solidFill>
-                  <a:srgbClr val="F1C40F"/>
-                </a:solidFill>
-              </a:rPr>
-              <a:t>La Solución: lector en streaming (Fase 2)</a:t>
-            </a:r>
-          </a:p>
-        </p:txBody>
-      </p:sp>
-      <p:sp>
-        <p:nvSpPr>
-          <p:cNvPr id="12" name="TextBox 11"/>
-          <p:cNvSpPr txBox="1"/>
-          <p:nvPr/>
-        </p:nvSpPr>
-        <p:spPr>
-          <a:xfrm>
-            <a:off x="6434175" y="1828800"/>
-            <a:ext cx="5190591" cy="4178808"/>
-          </a:xfrm>
-          <a:prstGeom prst="rect">
-            <a:avLst/>
-          </a:prstGeom>
-          <a:noFill/>
-        </p:spPr>
-        <p:txBody>
-          <a:bodyPr wrap="square">
-            <a:spAutoFit/>
-          </a:bodyPr>
-          <a:lstStyle/>
-          <a:p>
-            <a:pPr algn="l">
-              <a:lnSpc>
-                <a:spcPct val="110000"/>
-              </a:lnSpc>
-            </a:pPr>
-            <a:r>
-              <a:rPr sz="1700">
-                <a:solidFill>
-                  <a:srgbClr val="FBFCFD"/>
-                </a:solidFill>
-              </a:rPr>
-              <a:t>• </a:t>
-            </a:r>
-            <a:r>
-              <a:rPr sz="1700" b="1">
-                <a:solidFill>
-                  <a:srgbClr val="FBFCFD"/>
-                </a:solidFill>
-              </a:rPr>
-              <a:t>Lectura línea a línea</a:t>
-            </a:r>
-            <a:r>
-              <a:rPr sz="1700">
-                <a:solidFill>
-                  <a:srgbClr val="FBFCFD"/>
-                </a:solidFill>
-              </a:rPr>
-              <a:t> con el módulo </a:t>
-            </a:r>
-            <a:r>
-              <a:rPr sz="1600">
+              <a:rPr sz="1750">
+                <a:solidFill>
+                  <a:srgbClr val="FBFCFD"/>
+                </a:solidFill>
+              </a:rPr>
+              <a:t>. El pipeline implementa un lector en flujo (streaming) nativo que indexa selectivamente solo las 11 variables útiles. Posteriormente, se reemplazan los valores centinela </a:t>
+            </a:r>
+            <a:r>
+              <a:rPr sz="1650">
                 <a:solidFill>
                   <a:srgbClr val="7FDBFF"/>
                 </a:solidFill>
                 <a:latin typeface="Consolas"/>
               </a:rPr>
-              <a:t>csv</a:t>
-            </a:r>
-            <a:r>
-              <a:rPr sz="1700">
-                <a:solidFill>
-                  <a:srgbClr val="FBFCFD"/>
-                </a:solidFill>
-              </a:rPr>
-              <a:t> nativo: se indexan solo las </a:t>
-            </a:r>
-            <a:r>
-              <a:rPr sz="1700" b="1">
-                <a:solidFill>
-                  <a:srgbClr val="FBFCFD"/>
-                </a:solidFill>
-              </a:rPr>
-              <a:t>11 columnas clave por posición fija</a:t>
-            </a:r>
-            <a:r>
-              <a:rPr sz="1700">
-                <a:solidFill>
-                  <a:srgbClr val="FBFCFD"/>
-                </a:solidFill>
-              </a:rPr>
-              <a:t> y se descarta la cola I-V al vuelo.</a:t>
-            </a:r>
-          </a:p>
-          <a:p>
-            <a:pPr algn="l">
-              <a:lnSpc>
-                <a:spcPct val="110000"/>
-              </a:lnSpc>
-            </a:pPr>
-          </a:p>
-          <a:p>
-            <a:pPr algn="l">
-              <a:lnSpc>
-                <a:spcPct val="110000"/>
-              </a:lnSpc>
-            </a:pPr>
-            <a:r>
-              <a:rPr sz="1700">
-                <a:solidFill>
-                  <a:srgbClr val="FBFCFD"/>
-                </a:solidFill>
-              </a:rPr>
-              <a:t>• </a:t>
-            </a:r>
-            <a:r>
-              <a:rPr sz="1700" b="1">
-                <a:solidFill>
-                  <a:srgbClr val="FBFCFD"/>
-                </a:solidFill>
-              </a:rPr>
-              <a:t>Limpieza:</a:t>
-            </a:r>
-            <a:r>
-              <a:rPr sz="1700">
-                <a:solidFill>
-                  <a:srgbClr val="FBFCFD"/>
-                </a:solidFill>
-              </a:rPr>
-              <a:t> </a:t>
-            </a:r>
-            <a:r>
-              <a:rPr sz="1600">
+              <a:t>-9999</a:t>
+            </a:r>
+            <a:r>
+              <a:rPr sz="1750">
+                <a:solidFill>
+                  <a:srgbClr val="FBFCFD"/>
+                </a:solidFill>
+              </a:rPr>
+              <a:t> por </a:t>
+            </a:r>
+            <a:r>
+              <a:rPr sz="1650">
                 <a:solidFill>
                   <a:srgbClr val="7FDBFF"/>
                 </a:solidFill>
                 <a:latin typeface="Consolas"/>
               </a:rPr>
-              <a:t>-9999 → NaN</a:t>
-            </a:r>
-            <a:r>
-              <a:rPr sz="1700">
-                <a:solidFill>
-                  <a:srgbClr val="FBFCFD"/>
-                </a:solidFill>
-              </a:rPr>
-              <a:t>, </a:t>
-            </a:r>
-            <a:r>
-              <a:rPr sz="1600">
-                <a:solidFill>
-                  <a:srgbClr val="7FDBFF"/>
-                </a:solidFill>
-                <a:latin typeface="Consolas"/>
-              </a:rPr>
-              <a:t>dropna</a:t>
-            </a:r>
-            <a:r>
-              <a:rPr sz="1700">
-                <a:solidFill>
-                  <a:srgbClr val="FBFCFD"/>
-                </a:solidFill>
-              </a:rPr>
-              <a:t> sobre GHI/DNI/DHI/T_air y </a:t>
-            </a:r>
-            <a:r>
-              <a:rPr sz="1600">
-                <a:solidFill>
-                  <a:srgbClr val="7FDBFF"/>
-                </a:solidFill>
-                <a:latin typeface="Consolas"/>
-              </a:rPr>
-              <a:t>clip(≥0)</a:t>
-            </a:r>
-            <a:r>
-              <a:rPr sz="1700">
-                <a:solidFill>
-                  <a:srgbClr val="FBFCFD"/>
-                </a:solidFill>
-              </a:rPr>
-              <a:t> en irradiancias.</a:t>
-            </a:r>
-          </a:p>
-          <a:p>
-            <a:pPr algn="l">
-              <a:lnSpc>
-                <a:spcPct val="110000"/>
-              </a:lnSpc>
-            </a:pPr>
-          </a:p>
-          <a:p>
-            <a:pPr algn="l">
-              <a:lnSpc>
-                <a:spcPct val="110000"/>
-              </a:lnSpc>
-            </a:pPr>
-            <a:r>
-              <a:rPr sz="1700">
-                <a:solidFill>
-                  <a:srgbClr val="FBFCFD"/>
-                </a:solidFill>
-              </a:rPr>
-              <a:t>• </a:t>
-            </a:r>
-            <a:r>
-              <a:rPr sz="1700" b="1">
-                <a:solidFill>
-                  <a:srgbClr val="FBFCFD"/>
-                </a:solidFill>
-              </a:rPr>
-              <a:t>Resultado:</a:t>
-            </a:r>
-            <a:r>
-              <a:rPr sz="1700">
-                <a:solidFill>
-                  <a:srgbClr val="FBFCFD"/>
-                </a:solidFill>
-              </a:rPr>
-              <a:t> m-Si 35,669/36,765 filas válidas (97.0 %) · HIT 37,313/38,377 (97.2 %).</a:t>
-            </a:r>
-          </a:p>
-          <a:p>
-            <a:pPr algn="l">
-              <a:lnSpc>
-                <a:spcPct val="110000"/>
-              </a:lnSpc>
-            </a:pPr>
-          </a:p>
-          <a:p>
-            <a:pPr algn="l">
-              <a:lnSpc>
-                <a:spcPct val="110000"/>
-              </a:lnSpc>
-            </a:pPr>
-            <a:r>
-              <a:rPr sz="1700">
-                <a:solidFill>
-                  <a:srgbClr val="FBFCFD"/>
-                </a:solidFill>
-              </a:rPr>
-              <a:t>• Los registros nocturnos no existen en la base (solo se midió de día); no se requirió filtro nocturno adicional.</a:t>
-            </a:r>
-          </a:p>
-        </p:txBody>
-      </p:sp>
-      <p:sp>
-        <p:nvSpPr>
-          <p:cNvPr id="13" name="TextBox 12"/>
+              <a:t>NaN</a:t>
+            </a:r>
+            <a:r>
+              <a:rPr sz="1750">
+                <a:solidFill>
+                  <a:srgbClr val="FBFCFD"/>
+                </a:solidFill>
+              </a:rPr>
+              <a:t>, se descartan filas nulas y se recortan irradiancias negativas, logrando un 97.0 % (m-Si) y 97.2 % (HIT) de registros útiles para el modelado.</a:t>
+            </a:r>
+          </a:p>
+        </p:txBody>
+      </p:sp>
+      <p:sp>
+        <p:nvSpPr>
+          <p:cNvPr id="8" name="TextBox 7"/>
           <p:cNvSpPr txBox="1"/>
           <p:nvPr/>
         </p:nvSpPr>

</xml_diff>

<commit_message>
fix(presentation): adjust slide 3 table margins and position to prevent caption text overflow
</commit_message>
<xml_diff>
--- a/output/Presentacion_Final_ELI556_Atacama_POA_Tarea2_revisado.pptx
+++ b/output/Presentacion_Final_ELI556_Atacama_POA_Tarea2_revisado.pptx
@@ -7114,7 +7114,7 @@
               <a:tr h="420624">
                 <a:tc>
                   <a:txBody>
-                    <a:bodyPr wrap="square"/>
+                    <a:bodyPr wrap="square" lIns="54864" rIns="54864" tIns="36576" bIns="36576"/>
                     <a:lstStyle/>
                     <a:p>
                       <a:pPr algn="ctr"/>
@@ -7136,7 +7136,7 @@
                 </a:tc>
                 <a:tc>
                   <a:txBody>
-                    <a:bodyPr wrap="square"/>
+                    <a:bodyPr wrap="square" lIns="54864" rIns="54864" tIns="36576" bIns="36576"/>
                     <a:lstStyle/>
                     <a:p>
                       <a:pPr algn="ctr"/>
@@ -7158,7 +7158,7 @@
                 </a:tc>
                 <a:tc>
                   <a:txBody>
-                    <a:bodyPr wrap="square"/>
+                    <a:bodyPr wrap="square" lIns="54864" rIns="54864" tIns="36576" bIns="36576"/>
                     <a:lstStyle/>
                     <a:p>
                       <a:pPr algn="ctr"/>
@@ -7182,7 +7182,7 @@
               <a:tr h="420624">
                 <a:tc>
                   <a:txBody>
-                    <a:bodyPr wrap="square"/>
+                    <a:bodyPr wrap="square" lIns="54864" rIns="54864" tIns="36576" bIns="36576"/>
                     <a:lstStyle/>
                     <a:p>
                       <a:pPr algn="l"/>
@@ -7220,7 +7220,7 @@
                 </a:tc>
                 <a:tc>
                   <a:txBody>
-                    <a:bodyPr wrap="square"/>
+                    <a:bodyPr wrap="square" lIns="54864" rIns="54864" tIns="36576" bIns="36576"/>
                     <a:lstStyle/>
                     <a:p>
                       <a:pPr algn="ctr"/>
@@ -7242,7 +7242,7 @@
                 </a:tc>
                 <a:tc>
                   <a:txBody>
-                    <a:bodyPr wrap="square"/>
+                    <a:bodyPr wrap="square" lIns="54864" rIns="54864" tIns="36576" bIns="36576"/>
                     <a:lstStyle/>
                     <a:p>
                       <a:pPr algn="ctr"/>
@@ -7266,7 +7266,7 @@
               <a:tr h="420624">
                 <a:tc>
                   <a:txBody>
-                    <a:bodyPr wrap="square"/>
+                    <a:bodyPr wrap="square" lIns="54864" rIns="54864" tIns="36576" bIns="36576"/>
                     <a:lstStyle/>
                     <a:p>
                       <a:pPr algn="l"/>
@@ -7304,7 +7304,7 @@
                 </a:tc>
                 <a:tc>
                   <a:txBody>
-                    <a:bodyPr wrap="square"/>
+                    <a:bodyPr wrap="square" lIns="54864" rIns="54864" tIns="36576" bIns="36576"/>
                     <a:lstStyle/>
                     <a:p>
                       <a:pPr algn="ctr"/>
@@ -7334,7 +7334,7 @@
                 </a:tc>
                 <a:tc>
                   <a:txBody>
-                    <a:bodyPr wrap="square"/>
+                    <a:bodyPr wrap="square" lIns="54864" rIns="54864" tIns="36576" bIns="36576"/>
                     <a:lstStyle/>
                     <a:p>
                       <a:pPr algn="ctr"/>
@@ -7366,7 +7366,7 @@
               <a:tr h="420624">
                 <a:tc>
                   <a:txBody>
-                    <a:bodyPr wrap="square"/>
+                    <a:bodyPr wrap="square" lIns="54864" rIns="54864" tIns="36576" bIns="36576"/>
                     <a:lstStyle/>
                     <a:p>
                       <a:pPr algn="l"/>
@@ -7404,7 +7404,7 @@
                 </a:tc>
                 <a:tc>
                   <a:txBody>
-                    <a:bodyPr wrap="square"/>
+                    <a:bodyPr wrap="square" lIns="54864" rIns="54864" tIns="36576" bIns="36576"/>
                     <a:lstStyle/>
                     <a:p>
                       <a:pPr algn="ctr"/>
@@ -7426,7 +7426,7 @@
                 </a:tc>
                 <a:tc>
                   <a:txBody>
-                    <a:bodyPr wrap="square"/>
+                    <a:bodyPr wrap="square" lIns="54864" rIns="54864" tIns="36576" bIns="36576"/>
                     <a:lstStyle/>
                     <a:p>
                       <a:pPr algn="ctr"/>
@@ -7450,7 +7450,7 @@
               <a:tr h="420624">
                 <a:tc>
                   <a:txBody>
-                    <a:bodyPr wrap="square"/>
+                    <a:bodyPr wrap="square" lIns="54864" rIns="54864" tIns="36576" bIns="36576"/>
                     <a:lstStyle/>
                     <a:p>
                       <a:pPr algn="l"/>
@@ -7488,7 +7488,7 @@
                 </a:tc>
                 <a:tc>
                   <a:txBody>
-                    <a:bodyPr wrap="square"/>
+                    <a:bodyPr wrap="square" lIns="54864" rIns="54864" tIns="36576" bIns="36576"/>
                     <a:lstStyle/>
                     <a:p>
                       <a:pPr algn="ctr"/>
@@ -7510,7 +7510,7 @@
                 </a:tc>
                 <a:tc>
                   <a:txBody>
-                    <a:bodyPr wrap="square"/>
+                    <a:bodyPr wrap="square" lIns="54864" rIns="54864" tIns="36576" bIns="36576"/>
                     <a:lstStyle/>
                     <a:p>
                       <a:pPr algn="ctr"/>
@@ -7534,7 +7534,7 @@
               <a:tr h="420624">
                 <a:tc>
                   <a:txBody>
-                    <a:bodyPr wrap="square"/>
+                    <a:bodyPr wrap="square" lIns="54864" rIns="54864" tIns="36576" bIns="36576"/>
                     <a:lstStyle/>
                     <a:p>
                       <a:pPr algn="l"/>
@@ -7572,7 +7572,7 @@
                 </a:tc>
                 <a:tc>
                   <a:txBody>
-                    <a:bodyPr wrap="square"/>
+                    <a:bodyPr wrap="square" lIns="54864" rIns="54864" tIns="36576" bIns="36576"/>
                     <a:lstStyle/>
                     <a:p>
                       <a:pPr algn="ctr"/>
@@ -7594,7 +7594,7 @@
                 </a:tc>
                 <a:tc>
                   <a:txBody>
-                    <a:bodyPr wrap="square"/>
+                    <a:bodyPr wrap="square" lIns="54864" rIns="54864" tIns="36576" bIns="36576"/>
                     <a:lstStyle/>
                     <a:p>
                       <a:pPr algn="ctr"/>
@@ -7618,7 +7618,7 @@
               <a:tr h="420624">
                 <a:tc>
                   <a:txBody>
-                    <a:bodyPr wrap="square"/>
+                    <a:bodyPr wrap="square" lIns="54864" rIns="54864" tIns="36576" bIns="36576"/>
                     <a:lstStyle/>
                     <a:p>
                       <a:pPr algn="l"/>
@@ -7656,7 +7656,7 @@
                 </a:tc>
                 <a:tc>
                   <a:txBody>
-                    <a:bodyPr wrap="square"/>
+                    <a:bodyPr wrap="square" lIns="54864" rIns="54864" tIns="36576" bIns="36576"/>
                     <a:lstStyle/>
                     <a:p>
                       <a:pPr algn="ctr"/>
@@ -7678,7 +7678,7 @@
                 </a:tc>
                 <a:tc>
                   <a:txBody>
-                    <a:bodyPr wrap="square"/>
+                    <a:bodyPr wrap="square" lIns="54864" rIns="54864" tIns="36576" bIns="36576"/>
                     <a:lstStyle/>
                     <a:p>
                       <a:pPr algn="ctr"/>
@@ -7702,7 +7702,7 @@
               <a:tr h="420624">
                 <a:tc>
                   <a:txBody>
-                    <a:bodyPr wrap="square"/>
+                    <a:bodyPr wrap="square" lIns="54864" rIns="54864" tIns="36576" bIns="36576"/>
                     <a:lstStyle/>
                     <a:p>
                       <a:pPr algn="l"/>
@@ -7740,7 +7740,7 @@
                 </a:tc>
                 <a:tc>
                   <a:txBody>
-                    <a:bodyPr wrap="square"/>
+                    <a:bodyPr wrap="square" lIns="54864" rIns="54864" tIns="36576" bIns="36576"/>
                     <a:lstStyle/>
                     <a:p>
                       <a:pPr algn="ctr"/>
@@ -7762,7 +7762,7 @@
                 </a:tc>
                 <a:tc>
                   <a:txBody>
-                    <a:bodyPr wrap="square"/>
+                    <a:bodyPr wrap="square" lIns="54864" rIns="54864" tIns="36576" bIns="36576"/>
                     <a:lstStyle/>
                     <a:p>
                       <a:pPr algn="ctr"/>
@@ -7786,7 +7786,7 @@
               <a:tr h="420624">
                 <a:tc>
                   <a:txBody>
-                    <a:bodyPr wrap="square"/>
+                    <a:bodyPr wrap="square" lIns="54864" rIns="54864" tIns="36576" bIns="36576"/>
                     <a:lstStyle/>
                     <a:p>
                       <a:pPr algn="l"/>
@@ -7832,7 +7832,7 @@
                 </a:tc>
                 <a:tc>
                   <a:txBody>
-                    <a:bodyPr wrap="square"/>
+                    <a:bodyPr wrap="square" lIns="54864" rIns="54864" tIns="36576" bIns="36576"/>
                     <a:lstStyle/>
                     <a:p>
                       <a:pPr algn="ctr"/>
@@ -7854,7 +7854,7 @@
                 </a:tc>
                 <a:tc>
                   <a:txBody>
-                    <a:bodyPr wrap="square"/>
+                    <a:bodyPr wrap="square" lIns="54864" rIns="54864" tIns="36576" bIns="36576"/>
                     <a:lstStyle/>
                     <a:p>
                       <a:pPr algn="ctr"/>
@@ -7878,7 +7878,7 @@
               <a:tr h="420624">
                 <a:tc>
                   <a:txBody>
-                    <a:bodyPr wrap="square"/>
+                    <a:bodyPr wrap="square" lIns="54864" rIns="54864" tIns="36576" bIns="36576"/>
                     <a:lstStyle/>
                     <a:p>
                       <a:pPr algn="l"/>
@@ -7916,7 +7916,7 @@
                 </a:tc>
                 <a:tc>
                   <a:txBody>
-                    <a:bodyPr wrap="square"/>
+                    <a:bodyPr wrap="square" lIns="54864" rIns="54864" tIns="36576" bIns="36576"/>
                     <a:lstStyle/>
                     <a:p>
                       <a:pPr algn="ctr"/>
@@ -7938,7 +7938,7 @@
                 </a:tc>
                 <a:tc>
                   <a:txBody>
-                    <a:bodyPr wrap="square"/>
+                    <a:bodyPr wrap="square" lIns="54864" rIns="54864" tIns="36576" bIns="36576"/>
                     <a:lstStyle/>
                     <a:p>
                       <a:pPr algn="ctr"/>
@@ -17920,7 +17920,7 @@
         <p:spPr>
           <a:xfrm>
             <a:off x="365760" y="1188720"/>
-            <a:ext cx="11460175" cy="5029200"/>
+            <a:ext cx="11460175" cy="5212080"/>
           </a:xfrm>
           <a:prstGeom prst="rect">
             <a:avLst/>
@@ -17965,7 +17965,7 @@
         <p:spPr>
           <a:xfrm>
             <a:off x="365760" y="1188720"/>
-            <a:ext cx="73152" cy="5029200"/>
+            <a:ext cx="73152" cy="5212080"/>
           </a:xfrm>
           <a:prstGeom prst="rect">
             <a:avLst/>
@@ -18042,8 +18042,8 @@
           <p:nvPr/>
         </p:nvGraphicFramePr>
         <p:xfrm>
-          <a:off x="594360" y="1755648"/>
-          <a:ext cx="11002973" cy="3886200"/>
+          <a:off x="594360" y="1691640"/>
+          <a:ext cx="11002973" cy="3017520"/>
         </p:xfrm>
         <a:graphic>
           <a:graphicData uri="http://schemas.openxmlformats.org/drawingml/2006/table">
@@ -18058,15 +18058,15 @@
                 <a:gridCol w="3143707"/>
                 <a:gridCol w="2297324"/>
               </a:tblGrid>
-              <a:tr h="647700">
+              <a:tr h="502920">
                 <a:tc>
                   <a:txBody>
-                    <a:bodyPr wrap="square"/>
+                    <a:bodyPr wrap="square" lIns="54864" rIns="54864" tIns="36576" bIns="36576"/>
                     <a:lstStyle/>
                     <a:p>
                       <a:pPr algn="ctr"/>
                       <a:r>
-                        <a:rPr sz="1800" b="1">
+                        <a:rPr sz="1700" b="1">
                           <a:solidFill>
                             <a:srgbClr val="F1C40F"/>
                           </a:solidFill>
@@ -18083,12 +18083,12 @@
                 </a:tc>
                 <a:tc>
                   <a:txBody>
-                    <a:bodyPr wrap="square"/>
+                    <a:bodyPr wrap="square" lIns="54864" rIns="54864" tIns="36576" bIns="36576"/>
                     <a:lstStyle/>
                     <a:p>
                       <a:pPr algn="ctr"/>
                       <a:r>
-                        <a:rPr sz="1800" b="1">
+                        <a:rPr sz="1700" b="1">
                           <a:solidFill>
                             <a:srgbClr val="F1C40F"/>
                           </a:solidFill>
@@ -18105,12 +18105,12 @@
                 </a:tc>
                 <a:tc>
                   <a:txBody>
-                    <a:bodyPr wrap="square"/>
+                    <a:bodyPr wrap="square" lIns="54864" rIns="54864" tIns="36576" bIns="36576"/>
                     <a:lstStyle/>
                     <a:p>
                       <a:pPr algn="ctr"/>
                       <a:r>
-                        <a:rPr sz="1800" b="1">
+                        <a:rPr sz="1700" b="1">
                           <a:solidFill>
                             <a:srgbClr val="F1C40F"/>
                           </a:solidFill>
@@ -18127,12 +18127,12 @@
                 </a:tc>
                 <a:tc>
                   <a:txBody>
-                    <a:bodyPr wrap="square"/>
+                    <a:bodyPr wrap="square" lIns="54864" rIns="54864" tIns="36576" bIns="36576"/>
                     <a:lstStyle/>
                     <a:p>
                       <a:pPr algn="ctr"/>
                       <a:r>
-                        <a:rPr sz="1800" b="1">
+                        <a:rPr sz="1700" b="1">
                           <a:solidFill>
                             <a:srgbClr val="F1C40F"/>
                           </a:solidFill>
@@ -18149,12 +18149,12 @@
                 </a:tc>
                 <a:tc>
                   <a:txBody>
-                    <a:bodyPr wrap="square"/>
+                    <a:bodyPr wrap="square" lIns="54864" rIns="54864" tIns="36576" bIns="36576"/>
                     <a:lstStyle/>
                     <a:p>
                       <a:pPr algn="ctr"/>
                       <a:r>
-                        <a:rPr sz="1800" b="1">
+                        <a:rPr sz="1700" b="1">
                           <a:solidFill>
                             <a:srgbClr val="F1C40F"/>
                           </a:solidFill>
@@ -18170,15 +18170,15 @@
                   </a:tcPr>
                 </a:tc>
               </a:tr>
-              <a:tr h="647700">
+              <a:tr h="502920">
                 <a:tc>
                   <a:txBody>
-                    <a:bodyPr wrap="square"/>
+                    <a:bodyPr wrap="square" lIns="54864" rIns="54864" tIns="36576" bIns="36576"/>
                     <a:lstStyle/>
                     <a:p>
                       <a:pPr algn="l"/>
                       <a:r>
-                        <a:rPr sz="1650">
+                        <a:rPr sz="1500">
                           <a:solidFill>
                             <a:srgbClr val="FBFCFD"/>
                           </a:solidFill>
@@ -18196,12 +18196,12 @@
                 </a:tc>
                 <a:tc>
                   <a:txBody>
-                    <a:bodyPr wrap="square"/>
+                    <a:bodyPr wrap="square" lIns="54864" rIns="54864" tIns="36576" bIns="36576"/>
                     <a:lstStyle/>
                     <a:p>
                       <a:pPr algn="ctr"/>
                       <a:r>
-                        <a:rPr sz="1650">
+                        <a:rPr sz="1500">
                           <a:solidFill>
                             <a:srgbClr val="FBFCFD"/>
                           </a:solidFill>
@@ -18218,12 +18218,12 @@
                 </a:tc>
                 <a:tc>
                   <a:txBody>
-                    <a:bodyPr wrap="square"/>
+                    <a:bodyPr wrap="square" lIns="54864" rIns="54864" tIns="36576" bIns="36576"/>
                     <a:lstStyle/>
                     <a:p>
                       <a:pPr algn="ctr"/>
                       <a:r>
-                        <a:rPr sz="1650">
+                        <a:rPr sz="1500">
                           <a:solidFill>
                             <a:srgbClr val="FBFCFD"/>
                           </a:solidFill>
@@ -18240,12 +18240,12 @@
                 </a:tc>
                 <a:tc>
                   <a:txBody>
-                    <a:bodyPr wrap="square"/>
+                    <a:bodyPr wrap="square" lIns="54864" rIns="54864" tIns="36576" bIns="36576"/>
                     <a:lstStyle/>
                     <a:p>
                       <a:pPr algn="ctr"/>
                       <a:r>
-                        <a:rPr sz="1650">
+                        <a:rPr sz="1500">
                           <a:solidFill>
                             <a:srgbClr val="FBFCFD"/>
                           </a:solidFill>
@@ -18262,12 +18262,12 @@
                 </a:tc>
                 <a:tc>
                   <a:txBody>
-                    <a:bodyPr wrap="square"/>
+                    <a:bodyPr wrap="square" lIns="54864" rIns="54864" tIns="36576" bIns="36576"/>
                     <a:lstStyle/>
                     <a:p>
                       <a:pPr algn="ctr"/>
                       <a:r>
-                        <a:rPr sz="1650">
+                        <a:rPr sz="1500">
                           <a:solidFill>
                             <a:srgbClr val="FBFCFD"/>
                           </a:solidFill>
@@ -18283,15 +18283,15 @@
                   </a:tcPr>
                 </a:tc>
               </a:tr>
-              <a:tr h="647700">
+              <a:tr h="502920">
                 <a:tc>
                   <a:txBody>
-                    <a:bodyPr wrap="square"/>
+                    <a:bodyPr wrap="square" lIns="54864" rIns="54864" tIns="36576" bIns="36576"/>
                     <a:lstStyle/>
                     <a:p>
                       <a:pPr algn="l"/>
                       <a:r>
-                        <a:rPr sz="1650">
+                        <a:rPr sz="1500">
                           <a:solidFill>
                             <a:srgbClr val="FBFCFD"/>
                           </a:solidFill>
@@ -18309,12 +18309,12 @@
                 </a:tc>
                 <a:tc>
                   <a:txBody>
-                    <a:bodyPr wrap="square"/>
+                    <a:bodyPr wrap="square" lIns="54864" rIns="54864" tIns="36576" bIns="36576"/>
                     <a:lstStyle/>
                     <a:p>
                       <a:pPr algn="ctr"/>
                       <a:r>
-                        <a:rPr sz="1650">
+                        <a:rPr sz="1500">
                           <a:solidFill>
                             <a:srgbClr val="FBFCFD"/>
                           </a:solidFill>
@@ -18331,12 +18331,12 @@
                 </a:tc>
                 <a:tc>
                   <a:txBody>
-                    <a:bodyPr wrap="square"/>
+                    <a:bodyPr wrap="square" lIns="54864" rIns="54864" tIns="36576" bIns="36576"/>
                     <a:lstStyle/>
                     <a:p>
                       <a:pPr algn="ctr"/>
                       <a:r>
-                        <a:rPr sz="1650">
+                        <a:rPr sz="1500">
                           <a:solidFill>
                             <a:srgbClr val="FBFCFD"/>
                           </a:solidFill>
@@ -18353,12 +18353,12 @@
                 </a:tc>
                 <a:tc>
                   <a:txBody>
-                    <a:bodyPr wrap="square"/>
+                    <a:bodyPr wrap="square" lIns="54864" rIns="54864" tIns="36576" bIns="36576"/>
                     <a:lstStyle/>
                     <a:p>
                       <a:pPr algn="ctr"/>
                       <a:r>
-                        <a:rPr sz="1650">
+                        <a:rPr sz="1500">
                           <a:solidFill>
                             <a:srgbClr val="FBFCFD"/>
                           </a:solidFill>
@@ -18375,12 +18375,12 @@
                 </a:tc>
                 <a:tc>
                   <a:txBody>
-                    <a:bodyPr wrap="square"/>
+                    <a:bodyPr wrap="square" lIns="54864" rIns="54864" tIns="36576" bIns="36576"/>
                     <a:lstStyle/>
                     <a:p>
                       <a:pPr algn="ctr"/>
                       <a:r>
-                        <a:rPr sz="1650">
+                        <a:rPr sz="1500">
                           <a:solidFill>
                             <a:srgbClr val="FBFCFD"/>
                           </a:solidFill>
@@ -18396,15 +18396,15 @@
                   </a:tcPr>
                 </a:tc>
               </a:tr>
-              <a:tr h="647700">
+              <a:tr h="502920">
                 <a:tc>
                   <a:txBody>
-                    <a:bodyPr wrap="square"/>
+                    <a:bodyPr wrap="square" lIns="54864" rIns="54864" tIns="36576" bIns="36576"/>
                     <a:lstStyle/>
                     <a:p>
                       <a:pPr algn="l"/>
                       <a:r>
-                        <a:rPr sz="1650">
+                        <a:rPr sz="1500">
                           <a:solidFill>
                             <a:srgbClr val="FBFCFD"/>
                           </a:solidFill>
@@ -18422,12 +18422,12 @@
                 </a:tc>
                 <a:tc>
                   <a:txBody>
-                    <a:bodyPr wrap="square"/>
+                    <a:bodyPr wrap="square" lIns="54864" rIns="54864" tIns="36576" bIns="36576"/>
                     <a:lstStyle/>
                     <a:p>
                       <a:pPr algn="ctr"/>
                       <a:r>
-                        <a:rPr sz="1650">
+                        <a:rPr sz="1500">
                           <a:solidFill>
                             <a:srgbClr val="FBFCFD"/>
                           </a:solidFill>
@@ -18444,12 +18444,12 @@
                 </a:tc>
                 <a:tc>
                   <a:txBody>
-                    <a:bodyPr wrap="square"/>
+                    <a:bodyPr wrap="square" lIns="54864" rIns="54864" tIns="36576" bIns="36576"/>
                     <a:lstStyle/>
                     <a:p>
                       <a:pPr algn="ctr"/>
                       <a:r>
-                        <a:rPr sz="1650">
+                        <a:rPr sz="1500">
                           <a:solidFill>
                             <a:srgbClr val="FBFCFD"/>
                           </a:solidFill>
@@ -18466,12 +18466,12 @@
                 </a:tc>
                 <a:tc>
                   <a:txBody>
-                    <a:bodyPr wrap="square"/>
+                    <a:bodyPr wrap="square" lIns="54864" rIns="54864" tIns="36576" bIns="36576"/>
                     <a:lstStyle/>
                     <a:p>
                       <a:pPr algn="ctr"/>
                       <a:r>
-                        <a:rPr sz="1650">
+                        <a:rPr sz="1500">
                           <a:solidFill>
                             <a:srgbClr val="FBFCFD"/>
                           </a:solidFill>
@@ -18488,12 +18488,12 @@
                 </a:tc>
                 <a:tc>
                   <a:txBody>
-                    <a:bodyPr wrap="square"/>
+                    <a:bodyPr wrap="square" lIns="54864" rIns="54864" tIns="36576" bIns="36576"/>
                     <a:lstStyle/>
                     <a:p>
                       <a:pPr algn="ctr"/>
                       <a:r>
-                        <a:rPr sz="1650">
+                        <a:rPr sz="1500">
                           <a:solidFill>
                             <a:srgbClr val="FBFCFD"/>
                           </a:solidFill>
@@ -18509,15 +18509,15 @@
                   </a:tcPr>
                 </a:tc>
               </a:tr>
-              <a:tr h="647700">
+              <a:tr h="502920">
                 <a:tc>
                   <a:txBody>
-                    <a:bodyPr wrap="square"/>
+                    <a:bodyPr wrap="square" lIns="54864" rIns="54864" tIns="36576" bIns="36576"/>
                     <a:lstStyle/>
                     <a:p>
                       <a:pPr algn="l"/>
                       <a:r>
-                        <a:rPr sz="1650">
+                        <a:rPr sz="1500">
                           <a:solidFill>
                             <a:srgbClr val="FBFCFD"/>
                           </a:solidFill>
@@ -18535,12 +18535,12 @@
                 </a:tc>
                 <a:tc>
                   <a:txBody>
-                    <a:bodyPr wrap="square"/>
+                    <a:bodyPr wrap="square" lIns="54864" rIns="54864" tIns="36576" bIns="36576"/>
                     <a:lstStyle/>
                     <a:p>
                       <a:pPr algn="ctr"/>
                       <a:r>
-                        <a:rPr sz="1650">
+                        <a:rPr sz="1500">
                           <a:solidFill>
                             <a:srgbClr val="FBFCFD"/>
                           </a:solidFill>
@@ -18557,12 +18557,12 @@
                 </a:tc>
                 <a:tc>
                   <a:txBody>
-                    <a:bodyPr wrap="square"/>
+                    <a:bodyPr wrap="square" lIns="54864" rIns="54864" tIns="36576" bIns="36576"/>
                     <a:lstStyle/>
                     <a:p>
                       <a:pPr algn="ctr"/>
                       <a:r>
-                        <a:rPr sz="1650">
+                        <a:rPr sz="1500">
                           <a:solidFill>
                             <a:srgbClr val="FBFCFD"/>
                           </a:solidFill>
@@ -18579,12 +18579,12 @@
                 </a:tc>
                 <a:tc>
                   <a:txBody>
-                    <a:bodyPr wrap="square"/>
+                    <a:bodyPr wrap="square" lIns="54864" rIns="54864" tIns="36576" bIns="36576"/>
                     <a:lstStyle/>
                     <a:p>
                       <a:pPr algn="ctr"/>
                       <a:r>
-                        <a:rPr sz="1650">
+                        <a:rPr sz="1500">
                           <a:solidFill>
                             <a:srgbClr val="FBFCFD"/>
                           </a:solidFill>
@@ -18601,12 +18601,12 @@
                 </a:tc>
                 <a:tc>
                   <a:txBody>
-                    <a:bodyPr wrap="square"/>
+                    <a:bodyPr wrap="square" lIns="54864" rIns="54864" tIns="36576" bIns="36576"/>
                     <a:lstStyle/>
                     <a:p>
                       <a:pPr algn="ctr"/>
                       <a:r>
-                        <a:rPr sz="1650">
+                        <a:rPr sz="1500">
                           <a:solidFill>
                             <a:srgbClr val="FBFCFD"/>
                           </a:solidFill>
@@ -18622,15 +18622,15 @@
                   </a:tcPr>
                 </a:tc>
               </a:tr>
-              <a:tr h="647700">
+              <a:tr h="502920">
                 <a:tc>
                   <a:txBody>
-                    <a:bodyPr wrap="square"/>
+                    <a:bodyPr wrap="square" lIns="54864" rIns="54864" tIns="36576" bIns="36576"/>
                     <a:lstStyle/>
                     <a:p>
                       <a:pPr algn="l"/>
                       <a:r>
-                        <a:rPr sz="1650">
+                        <a:rPr sz="1500">
                           <a:solidFill>
                             <a:srgbClr val="FBFCFD"/>
                           </a:solidFill>
@@ -18648,12 +18648,12 @@
                 </a:tc>
                 <a:tc>
                   <a:txBody>
-                    <a:bodyPr wrap="square"/>
+                    <a:bodyPr wrap="square" lIns="54864" rIns="54864" tIns="36576" bIns="36576"/>
                     <a:lstStyle/>
                     <a:p>
                       <a:pPr algn="ctr"/>
                       <a:r>
-                        <a:rPr sz="1650">
+                        <a:rPr sz="1500">
                           <a:solidFill>
                             <a:srgbClr val="FBFCFD"/>
                           </a:solidFill>
@@ -18670,12 +18670,12 @@
                 </a:tc>
                 <a:tc>
                   <a:txBody>
-                    <a:bodyPr wrap="square"/>
+                    <a:bodyPr wrap="square" lIns="54864" rIns="54864" tIns="36576" bIns="36576"/>
                     <a:lstStyle/>
                     <a:p>
                       <a:pPr algn="ctr"/>
                       <a:r>
-                        <a:rPr sz="1650">
+                        <a:rPr sz="1500">
                           <a:solidFill>
                             <a:srgbClr val="FBFCFD"/>
                           </a:solidFill>
@@ -18692,12 +18692,12 @@
                 </a:tc>
                 <a:tc>
                   <a:txBody>
-                    <a:bodyPr wrap="square"/>
+                    <a:bodyPr wrap="square" lIns="54864" rIns="54864" tIns="36576" bIns="36576"/>
                     <a:lstStyle/>
                     <a:p>
                       <a:pPr algn="ctr"/>
                       <a:r>
-                        <a:rPr sz="1650">
+                        <a:rPr sz="1500">
                           <a:solidFill>
                             <a:srgbClr val="FBFCFD"/>
                           </a:solidFill>
@@ -18714,12 +18714,12 @@
                 </a:tc>
                 <a:tc>
                   <a:txBody>
-                    <a:bodyPr wrap="square"/>
+                    <a:bodyPr wrap="square" lIns="54864" rIns="54864" tIns="36576" bIns="36576"/>
                     <a:lstStyle/>
                     <a:p>
                       <a:pPr algn="ctr"/>
                       <a:r>
-                        <a:rPr sz="1650">
+                        <a:rPr sz="1500">
                           <a:solidFill>
                             <a:srgbClr val="FBFCFD"/>
                           </a:solidFill>
@@ -18747,7 +18747,7 @@
         </p:nvSpPr>
         <p:spPr>
           <a:xfrm>
-            <a:off x="594360" y="5742432"/>
+            <a:off x="594360" y="5349240"/>
             <a:ext cx="11002975" cy="457200"/>
           </a:xfrm>
           <a:prstGeom prst="rect">
@@ -18763,7 +18763,7 @@
           <a:p>
             <a:pPr algn="l"/>
             <a:r>
-              <a:rPr sz="1700">
+              <a:rPr sz="1550">
                 <a:solidFill>
                   <a:srgbClr val="9AA5B1"/>
                 </a:solidFill>
@@ -18771,7 +18771,7 @@
               <a:t>Criterio: máximo contraste térmico entre tecnologías comerciales viables, con datos experimentales completos en el dataset (</a:t>
             </a:r>
             <a:r>
-              <a:rPr sz="1600">
+              <a:rPr sz="1450">
                 <a:solidFill>
                   <a:srgbClr val="7FDBFF"/>
                 </a:solidFill>
@@ -18780,7 +18780,7 @@
               <a:t>mSi0166</a:t>
             </a:r>
             <a:r>
-              <a:rPr sz="1700">
+              <a:rPr sz="1550">
                 <a:solidFill>
                   <a:srgbClr val="9AA5B1"/>
                 </a:solidFill>
@@ -18788,7 +18788,7 @@
               <a:t> y </a:t>
             </a:r>
             <a:r>
-              <a:rPr sz="1600">
+              <a:rPr sz="1450">
                 <a:solidFill>
                   <a:srgbClr val="7FDBFF"/>
                 </a:solidFill>
@@ -18797,7 +18797,7 @@
               <a:t>HIT05667</a:t>
             </a:r>
             <a:r>
-              <a:rPr sz="1700">
+              <a:rPr sz="1550">
                 <a:solidFill>
                   <a:srgbClr val="9AA5B1"/>
                 </a:solidFill>

</xml_diff>

<commit_message>
fix: rediseño de diagramas y correcciones visuales de solapamiento en slides 5, 8, 9 y 15
</commit_message>
<xml_diff>
--- a/output/Presentacion_Final_ELI556_Atacama_POA_Tarea2_revisado.pptx
+++ b/output/Presentacion_Final_ELI556_Atacama_POA_Tarea2_revisado.pptx
@@ -5619,8 +5619,8 @@
         </p:nvSpPr>
         <p:spPr>
           <a:xfrm>
-            <a:off x="365760" y="2788920"/>
-            <a:ext cx="5592927" cy="3337560"/>
+            <a:off x="365760" y="2724912"/>
+            <a:ext cx="5592927" cy="3584448"/>
           </a:xfrm>
           <a:prstGeom prst="rect">
             <a:avLst/>
@@ -5664,8 +5664,8 @@
         </p:nvSpPr>
         <p:spPr>
           <a:xfrm>
-            <a:off x="365760" y="2788920"/>
-            <a:ext cx="73152" cy="3337560"/>
+            <a:off x="365760" y="2724912"/>
+            <a:ext cx="73152" cy="3584448"/>
           </a:xfrm>
           <a:prstGeom prst="rect">
             <a:avLst/>
@@ -5707,7 +5707,7 @@
         </p:nvSpPr>
         <p:spPr>
           <a:xfrm>
-            <a:off x="530352" y="2880360"/>
+            <a:off x="530352" y="2816352"/>
             <a:ext cx="5318607" cy="411480"/>
           </a:xfrm>
           <a:prstGeom prst="rect">
@@ -5741,8 +5741,8 @@
         </p:nvSpPr>
         <p:spPr>
           <a:xfrm>
-            <a:off x="566928" y="3429000"/>
-            <a:ext cx="5190591" cy="2532888"/>
+            <a:off x="566928" y="3364992"/>
+            <a:ext cx="5190591" cy="2779776"/>
           </a:xfrm>
           <a:prstGeom prst="rect">
             <a:avLst/>
@@ -5761,7 +5761,7 @@
               </a:lnSpc>
             </a:pPr>
             <a:r>
-              <a:rPr sz="1750">
+              <a:rPr sz="1500">
                 <a:solidFill>
                   <a:srgbClr val="FBFCFD"/>
                 </a:solidFill>
@@ -5769,7 +5769,7 @@
               <a:t>• </a:t>
             </a:r>
             <a:r>
-              <a:rPr sz="1750" b="1">
+              <a:rPr sz="1500" b="1">
                 <a:solidFill>
                   <a:srgbClr val="FBFCFD"/>
                 </a:solidFill>
@@ -5777,12 +5777,12 @@
               <a:t>Superposición de mediciones:</a:t>
             </a:r>
             <a:r>
-              <a:rPr sz="1750">
-                <a:solidFill>
-                  <a:srgbClr val="FBFCFD"/>
-                </a:solidFill>
-              </a:rPr>
-              <a:t> Las curvas de irradiancia diaria de los 11 archivos se superponen con exactitud, confirmando la consistencia del instrumental experimental.</a:t>
+              <a:rPr sz="1500">
+                <a:solidFill>
+                  <a:srgbClr val="FBFCFD"/>
+                </a:solidFill>
+              </a:rPr>
+              <a:t> Las curvas de irradiancia diaria se superponen con exactitud, confirmando la consistencia instrumental.</a:t>
             </a:r>
           </a:p>
           <a:p>
@@ -5799,7 +5799,7 @@
               </a:lnSpc>
             </a:pPr>
             <a:r>
-              <a:rPr sz="1750">
+              <a:rPr sz="1500">
                 <a:solidFill>
                   <a:srgbClr val="FBFCFD"/>
                 </a:solidFill>
@@ -5807,7 +5807,7 @@
               <a:t>• </a:t>
             </a:r>
             <a:r>
-              <a:rPr sz="1750" b="1">
+              <a:rPr sz="1500" b="1">
                 <a:solidFill>
                   <a:srgbClr val="FBFCFD"/>
                 </a:solidFill>
@@ -5815,7 +5815,7 @@
               <a:t>Rango temporal:</a:t>
             </a:r>
             <a:r>
-              <a:rPr sz="1750">
+              <a:rPr sz="1500">
                 <a:solidFill>
                   <a:srgbClr val="FBFCFD"/>
                 </a:solidFill>
@@ -5823,7 +5823,7 @@
               <a:t> Campaña desde el </a:t>
             </a:r>
             <a:r>
-              <a:rPr sz="1750" b="1">
+              <a:rPr sz="1500" b="1">
                 <a:solidFill>
                   <a:srgbClr val="FBFCFD"/>
                 </a:solidFill>
@@ -5831,15 +5831,15 @@
               <a:t>21 de enero de 2011</a:t>
             </a:r>
             <a:r>
-              <a:rPr sz="1750">
-                <a:solidFill>
-                  <a:srgbClr val="FBFCFD"/>
-                </a:solidFill>
-              </a:rPr>
-              <a:t> hasta el </a:t>
-            </a:r>
-            <a:r>
-              <a:rPr sz="1750" b="1">
+              <a:rPr sz="1500">
+                <a:solidFill>
+                  <a:srgbClr val="FBFCFD"/>
+                </a:solidFill>
+              </a:rPr>
+              <a:t> al </a:t>
+            </a:r>
+            <a:r>
+              <a:rPr sz="1500" b="1">
                 <a:solidFill>
                   <a:srgbClr val="FBFCFD"/>
                 </a:solidFill>
@@ -5847,7 +5847,7 @@
               <a:t>4 de marzo de 2012</a:t>
             </a:r>
             <a:r>
-              <a:rPr sz="1750">
+              <a:rPr sz="1500">
                 <a:solidFill>
                   <a:srgbClr val="FBFCFD"/>
                 </a:solidFill>
@@ -5869,7 +5869,7 @@
               </a:lnSpc>
             </a:pPr>
             <a:r>
-              <a:rPr sz="1750">
+              <a:rPr sz="1500">
                 <a:solidFill>
                   <a:srgbClr val="FBFCFD"/>
                 </a:solidFill>
@@ -5877,7 +5877,7 @@
               <a:t>• </a:t>
             </a:r>
             <a:r>
-              <a:rPr sz="1750" b="1">
+              <a:rPr sz="1500" b="1">
                 <a:solidFill>
                   <a:srgbClr val="FBFCFD"/>
                 </a:solidFill>
@@ -5885,12 +5885,12 @@
               <a:t>Tratamiento:</a:t>
             </a:r>
             <a:r>
-              <a:rPr sz="1750">
-                <a:solidFill>
-                  <a:srgbClr val="FBFCFD"/>
-                </a:solidFill>
-              </a:rPr>
-              <a:t> Se calcula la mediana diaria suavizada con una ventana de 7 días por cada archivo para aislar ruidos y nubes transitorias.</a:t>
+              <a:rPr sz="1500">
+                <a:solidFill>
+                  <a:srgbClr val="FBFCFD"/>
+                </a:solidFill>
+              </a:rPr>
+              <a:t> Mediana diaria suavizada (ventana 7 días) por archivo para aislar ruidos y nubes transitorias.</a:t>
             </a:r>
           </a:p>
         </p:txBody>
@@ -5903,8 +5903,8 @@
         </p:nvSpPr>
         <p:spPr>
           <a:xfrm>
-            <a:off x="6233007" y="2788920"/>
-            <a:ext cx="5592927" cy="3337560"/>
+            <a:off x="6233007" y="2724912"/>
+            <a:ext cx="5592927" cy="3584448"/>
           </a:xfrm>
           <a:prstGeom prst="rect">
             <a:avLst/>
@@ -5948,8 +5948,8 @@
         </p:nvSpPr>
         <p:spPr>
           <a:xfrm>
-            <a:off x="6233007" y="2788920"/>
-            <a:ext cx="73152" cy="3337560"/>
+            <a:off x="6233007" y="2724912"/>
+            <a:ext cx="73152" cy="3584448"/>
           </a:xfrm>
           <a:prstGeom prst="rect">
             <a:avLst/>
@@ -5991,7 +5991,7 @@
         </p:nvSpPr>
         <p:spPr>
           <a:xfrm>
-            <a:off x="6397599" y="2880360"/>
+            <a:off x="6397599" y="2816352"/>
             <a:ext cx="5318607" cy="411480"/>
           </a:xfrm>
           <a:prstGeom prst="rect">
@@ -6025,8 +6025,8 @@
         </p:nvSpPr>
         <p:spPr>
           <a:xfrm>
-            <a:off x="6434175" y="3429000"/>
-            <a:ext cx="5190591" cy="2532888"/>
+            <a:off x="6434175" y="3364992"/>
+            <a:ext cx="5190591" cy="2779776"/>
           </a:xfrm>
           <a:prstGeom prst="rect">
             <a:avLst/>
@@ -6045,7 +6045,7 @@
               </a:lnSpc>
             </a:pPr>
             <a:r>
-              <a:rPr sz="1750">
+              <a:rPr sz="1500">
                 <a:solidFill>
                   <a:srgbClr val="FBFCFD"/>
                 </a:solidFill>
@@ -6053,7 +6053,7 @@
               <a:t>• </a:t>
             </a:r>
             <a:r>
-              <a:rPr sz="1750" b="1">
+              <a:rPr sz="1500" b="1">
                 <a:solidFill>
                   <a:srgbClr val="FBFCFD"/>
                 </a:solidFill>
@@ -6061,15 +6061,15 @@
               <a:t>Validación previa:</a:t>
             </a:r>
             <a:r>
-              <a:rPr sz="1750">
-                <a:solidFill>
-                  <a:srgbClr val="FBFCFD"/>
-                </a:solidFill>
-              </a:rPr>
-              <a:t> El objetivo es validar la homogeneidad física de la radiación medida </a:t>
-            </a:r>
-            <a:r>
-              <a:rPr sz="1750" b="1">
+              <a:rPr sz="1500">
+                <a:solidFill>
+                  <a:srgbClr val="FBFCFD"/>
+                </a:solidFill>
+              </a:rPr>
+              <a:t> Confirmar la homogeneidad física de la radiación </a:t>
+            </a:r>
+            <a:r>
+              <a:rPr sz="1500" b="1">
                 <a:solidFill>
                   <a:srgbClr val="FBFCFD"/>
                 </a:solidFill>
@@ -6077,12 +6077,12 @@
               <a:t>antes</a:t>
             </a:r>
             <a:r>
-              <a:rPr sz="1750">
-                <a:solidFill>
-                  <a:srgbClr val="FBFCFD"/>
-                </a:solidFill>
-              </a:rPr>
-              <a:t> de procesar la emulación geográfica y el modelado de celdas.</a:t>
+              <a:rPr sz="1500">
+                <a:solidFill>
+                  <a:srgbClr val="FBFCFD"/>
+                </a:solidFill>
+              </a:rPr>
+              <a:t> de la emulación geográfica y el modelado.</a:t>
             </a:r>
           </a:p>
           <a:p>
@@ -6099,7 +6099,7 @@
               </a:lnSpc>
             </a:pPr>
             <a:r>
-              <a:rPr sz="1750">
+              <a:rPr sz="1500">
                 <a:solidFill>
                   <a:srgbClr val="FBFCFD"/>
                 </a:solidFill>
@@ -6107,20 +6107,20 @@
               <a:t>• </a:t>
             </a:r>
             <a:r>
-              <a:rPr sz="1750" b="1">
-                <a:solidFill>
-                  <a:srgbClr val="FBFCFD"/>
-                </a:solidFill>
-              </a:rPr>
-              <a:t>Evidencia de soiling y mantenimiento:</a:t>
-            </a:r>
-            <a:r>
-              <a:rPr sz="1750">
-                <a:solidFill>
-                  <a:srgbClr val="FBFCFD"/>
-                </a:solidFill>
-              </a:rPr>
-              <a:t> La perfecta coincidencia de las curvas demuestra que no hay desviaciones locales significativas en los sensores de referencia.</a:t>
+              <a:rPr sz="1500" b="1">
+                <a:solidFill>
+                  <a:srgbClr val="FBFCFD"/>
+                </a:solidFill>
+              </a:rPr>
+              <a:t>Soiling y mantenimiento:</a:t>
+            </a:r>
+            <a:r>
+              <a:rPr sz="1500">
+                <a:solidFill>
+                  <a:srgbClr val="FBFCFD"/>
+                </a:solidFill>
+              </a:rPr>
+              <a:t> La coincidencia de curvas demuestra que no hay desviaciones locales significativas en los sensores de referencia.</a:t>
             </a:r>
           </a:p>
           <a:p>
@@ -6137,7 +6137,7 @@
               </a:lnSpc>
             </a:pPr>
             <a:r>
-              <a:rPr sz="1750">
+              <a:rPr sz="1500">
                 <a:solidFill>
                   <a:srgbClr val="FBFCFD"/>
                 </a:solidFill>
@@ -6145,7 +6145,7 @@
               <a:t>• </a:t>
             </a:r>
             <a:r>
-              <a:rPr sz="1750" b="1">
+              <a:rPr sz="1500" b="1">
                 <a:solidFill>
                   <a:srgbClr val="FBFCFD"/>
                 </a:solidFill>
@@ -6153,12 +6153,12 @@
               <a:t>Alineación de sensores:</a:t>
             </a:r>
             <a:r>
-              <a:rPr sz="1750">
-                <a:solidFill>
-                  <a:srgbClr val="FBFCFD"/>
-                </a:solidFill>
-              </a:rPr>
-              <a:t> Se asegura que la irradiancia incidente en los 11 planos de módulo sea idéntica para una comparación tecnológica justa.</a:t>
+              <a:rPr sz="1500">
+                <a:solidFill>
+                  <a:srgbClr val="FBFCFD"/>
+                </a:solidFill>
+              </a:rPr>
+              <a:t> Garantizar que la irradiancia incidente en los 11 planos sea idéntica para una comparación justa.</a:t>
             </a:r>
           </a:p>
         </p:txBody>
@@ -26709,7 +26709,7 @@
                   <a:srgbClr val="F1C40F"/>
                 </a:solidFill>
               </a:rPr>
-              <a:t>Procedimiento: Arquitectura del Pipeline de Simulación (Fases 0–7)</a:t>
+              <a:t>Procedimiento: Arquitectura del Pipeline de Simulación (Fases 0–4)</a:t>
             </a:r>
           </a:p>
         </p:txBody>
@@ -26826,8 +26826,8 @@
         </p:blipFill>
         <p:spPr>
           <a:xfrm>
-            <a:off x="2529687" y="1188720"/>
-            <a:ext cx="7132320" cy="3566160"/>
+            <a:off x="380847" y="1188720"/>
+            <a:ext cx="11430000" cy="3325090"/>
           </a:xfrm>
           <a:prstGeom prst="rect">
             <a:avLst/>
@@ -26842,8 +26842,8 @@
         </p:nvSpPr>
         <p:spPr>
           <a:xfrm>
-            <a:off x="365760" y="4846320"/>
-            <a:ext cx="11460175" cy="1554480"/>
+            <a:off x="365760" y="5120640"/>
+            <a:ext cx="11460175" cy="1188720"/>
           </a:xfrm>
           <a:prstGeom prst="rect">
             <a:avLst/>
@@ -26887,8 +26887,8 @@
         </p:nvSpPr>
         <p:spPr>
           <a:xfrm>
-            <a:off x="548640" y="4882896"/>
-            <a:ext cx="11094415" cy="1481328"/>
+            <a:off x="548640" y="5157216"/>
+            <a:ext cx="11094415" cy="1115568"/>
           </a:xfrm>
           <a:prstGeom prst="rect">
             <a:avLst/>
@@ -26912,7 +26912,7 @@
                   <a:srgbClr val="FBFCFD"/>
                 </a:solidFill>
               </a:rPr>
-              <a:t>Flujo lógico de la simulación:</a:t>
+              <a:t>Flujo lógico de la simulación (Fases 0-4):</a:t>
             </a:r>
             <a:r>
               <a:rPr sz="1700">
@@ -26920,7 +26920,7 @@
                   <a:srgbClr val="FBFCFD"/>
                 </a:solidFill>
               </a:rPr>
-              <a:t> El proceso inicia con la exploración y emulación estacional de los datos (Fases 0-1) para adaptarlos al hemisferio sur. Luego, se limpia y calcula el recurso solar efectivo (Fase 2) y se extraen los parámetros físicos de los módulos (Fase 3). Finalmente, se realiza la simulación horaria (Fase 4) para graficar, documentar y exportar los resultados (Fases 5-7).</a:t>
+              <a:t> El proceso inicia con la exploración y emulación estacional de los datos (Fases 0-1) para adaptarlos al hemisferio sur. Luego, se limpia y calcula el recurso solar efectivo (Fase 2) y se extraen los parámetros físicos de los módulos (Fase 3). Finalmente, se realiza la simulación horaria dinámica (Fase 4) para obtener las series temporales de potencia y PR.</a:t>
             </a:r>
           </a:p>
         </p:txBody>
@@ -29148,8 +29148,8 @@
         </p:blipFill>
         <p:spPr>
           <a:xfrm>
-            <a:off x="895197" y="1097280"/>
-            <a:ext cx="10401300" cy="3657600"/>
+            <a:off x="570156" y="1143000"/>
+            <a:ext cx="11051381" cy="3886200"/>
           </a:xfrm>
           <a:prstGeom prst="rect">
             <a:avLst/>
@@ -29164,8 +29164,8 @@
         </p:nvSpPr>
         <p:spPr>
           <a:xfrm>
-            <a:off x="365760" y="4846320"/>
-            <a:ext cx="11460175" cy="1554480"/>
+            <a:off x="365760" y="5120640"/>
+            <a:ext cx="11460175" cy="1188720"/>
           </a:xfrm>
           <a:prstGeom prst="rect">
             <a:avLst/>
@@ -29209,8 +29209,8 @@
         </p:nvSpPr>
         <p:spPr>
           <a:xfrm>
-            <a:off x="548640" y="4882896"/>
-            <a:ext cx="11094415" cy="1481328"/>
+            <a:off x="548640" y="5157216"/>
+            <a:ext cx="11094415" cy="1115568"/>
           </a:xfrm>
           <a:prstGeom prst="rect">
             <a:avLst/>
@@ -29454,8 +29454,8 @@
         </p:blipFill>
         <p:spPr>
           <a:xfrm>
-            <a:off x="895197" y="1097280"/>
-            <a:ext cx="10401300" cy="3657600"/>
+            <a:off x="380847" y="1097280"/>
+            <a:ext cx="11430000" cy="2909454"/>
           </a:xfrm>
           <a:prstGeom prst="rect">
             <a:avLst/>
@@ -29471,7 +29471,7 @@
         <p:spPr>
           <a:xfrm>
             <a:off x="365760" y="4846320"/>
-            <a:ext cx="11460175" cy="1600200"/>
+            <a:ext cx="11460175" cy="1463040"/>
           </a:xfrm>
           <a:prstGeom prst="rect">
             <a:avLst/>
@@ -29516,7 +29516,7 @@
         <p:spPr>
           <a:xfrm>
             <a:off x="548640" y="4882896"/>
-            <a:ext cx="11094415" cy="1527048"/>
+            <a:ext cx="11094415" cy="1389888"/>
           </a:xfrm>
           <a:prstGeom prst="rect">
             <a:avLst/>

</xml_diff>

<commit_message>
Actualizacion de diagramas, procesamiento de datos POA CMP22 y ajustes en la presentacion final (Fase 6 y Anexos)
</commit_message>
<xml_diff>
--- a/output/Presentacion_Final_ELI556_Atacama_POA_Tarea2_revisado.pptx
+++ b/output/Presentacion_Final_ELI556_Atacama_POA_Tarea2_revisado.pptx
@@ -13778,7 +13778,7 @@
                   <a:srgbClr val="FBFCFD"/>
                 </a:solidFill>
               </a:rPr>
-              <a:t>, máx. simulado 73.3 °C).</a:t>
+              <a:t>).</a:t>
             </a:r>
           </a:p>
           <a:p>
@@ -19719,11 +19719,11 @@
           <a:p>
             <a:pPr algn="l">
               <a:lnSpc>
-                <a:spcPct val="108000"/>
+                <a:spcPct val="105000"/>
               </a:lnSpc>
             </a:pPr>
             <a:r>
-              <a:rPr sz="1550">
+              <a:rPr sz="1450">
                 <a:solidFill>
                   <a:srgbClr val="FBFCFD"/>
                 </a:solidFill>
@@ -19734,18 +19734,18 @@
           <a:p>
             <a:pPr algn="l">
               <a:lnSpc>
-                <a:spcPct val="108000"/>
+                <a:spcPct val="105000"/>
               </a:lnSpc>
             </a:pPr>
           </a:p>
           <a:p>
             <a:pPr algn="l">
               <a:lnSpc>
-                <a:spcPct val="108000"/>
+                <a:spcPct val="105000"/>
               </a:lnSpc>
             </a:pPr>
             <a:r>
-              <a:rPr sz="1550">
+              <a:rPr sz="1450">
                 <a:solidFill>
                   <a:srgbClr val="FBFCFD"/>
                 </a:solidFill>
@@ -19756,18 +19756,18 @@
           <a:p>
             <a:pPr algn="l">
               <a:lnSpc>
-                <a:spcPct val="108000"/>
+                <a:spcPct val="105000"/>
               </a:lnSpc>
             </a:pPr>
           </a:p>
           <a:p>
             <a:pPr algn="l">
               <a:lnSpc>
-                <a:spcPct val="108000"/>
+                <a:spcPct val="105000"/>
               </a:lnSpc>
             </a:pPr>
             <a:r>
-              <a:rPr sz="1550">
+              <a:rPr sz="1450">
                 <a:solidFill>
                   <a:srgbClr val="FBFCFD"/>
                 </a:solidFill>
@@ -19778,18 +19778,18 @@
           <a:p>
             <a:pPr algn="l">
               <a:lnSpc>
-                <a:spcPct val="108000"/>
+                <a:spcPct val="105000"/>
               </a:lnSpc>
             </a:pPr>
           </a:p>
           <a:p>
             <a:pPr algn="l">
               <a:lnSpc>
-                <a:spcPct val="108000"/>
+                <a:spcPct val="105000"/>
               </a:lnSpc>
             </a:pPr>
             <a:r>
-              <a:rPr sz="1550">
+              <a:rPr sz="1450">
                 <a:solidFill>
                   <a:srgbClr val="FBFCFD"/>
                 </a:solidFill>
@@ -19800,18 +19800,18 @@
           <a:p>
             <a:pPr algn="l">
               <a:lnSpc>
-                <a:spcPct val="108000"/>
+                <a:spcPct val="105000"/>
               </a:lnSpc>
             </a:pPr>
           </a:p>
           <a:p>
             <a:pPr algn="l">
               <a:lnSpc>
-                <a:spcPct val="108000"/>
+                <a:spcPct val="105000"/>
               </a:lnSpc>
             </a:pPr>
             <a:r>
-              <a:rPr sz="1550">
+              <a:rPr sz="1450">
                 <a:solidFill>
                   <a:srgbClr val="FBFCFD"/>
                 </a:solidFill>
@@ -19822,18 +19822,18 @@
           <a:p>
             <a:pPr algn="l">
               <a:lnSpc>
-                <a:spcPct val="108000"/>
+                <a:spcPct val="105000"/>
               </a:lnSpc>
             </a:pPr>
           </a:p>
           <a:p>
             <a:pPr algn="l">
               <a:lnSpc>
-                <a:spcPct val="108000"/>
+                <a:spcPct val="105000"/>
               </a:lnSpc>
             </a:pPr>
             <a:r>
-              <a:rPr sz="1550">
+              <a:rPr sz="1450">
                 <a:solidFill>
                   <a:srgbClr val="FBFCFD"/>
                 </a:solidFill>
@@ -19844,18 +19844,40 @@
           <a:p>
             <a:pPr algn="l">
               <a:lnSpc>
-                <a:spcPct val="108000"/>
+                <a:spcPct val="105000"/>
               </a:lnSpc>
             </a:pPr>
           </a:p>
           <a:p>
             <a:pPr algn="l">
               <a:lnSpc>
-                <a:spcPct val="108000"/>
+                <a:spcPct val="105000"/>
               </a:lnSpc>
             </a:pPr>
             <a:r>
-              <a:rPr sz="1550">
+              <a:rPr sz="1450">
+                <a:solidFill>
+                  <a:srgbClr val="FBFCFD"/>
+                </a:solidFill>
+              </a:rPr>
+              <a:t>7. PVGIS — Photovoltaic Geographical Information System, Joint Research Centre (Comisión Europea), base SARAH — recurso TMY de Atacama (Fase 8).</a:t>
+            </a:r>
+          </a:p>
+          <a:p>
+            <a:pPr algn="l">
+              <a:lnSpc>
+                <a:spcPct val="105000"/>
+              </a:lnSpc>
+            </a:pPr>
+          </a:p>
+          <a:p>
+            <a:pPr algn="l">
+              <a:lnSpc>
+                <a:spcPct val="105000"/>
+              </a:lnSpc>
+            </a:pPr>
+            <a:r>
+              <a:rPr sz="1450">
                 <a:solidFill>
                   <a:srgbClr val="FBFCFD"/>
                 </a:solidFill>
@@ -28215,7 +28237,7 @@
                   <a:srgbClr val="F1C40F"/>
                 </a:solidFill>
               </a:rPr>
-              <a:t> = 1.121 eV (Si, 25 °C); S = G</a:t>
+              <a:t> = 1.121 eV (Si); S = irradiancia efectiva = G</a:t>
             </a:r>
             <a:r>
               <a:rPr sz="1150">
@@ -28231,7 +28253,7 @@
                   <a:srgbClr val="F1C40F"/>
                 </a:solidFill>
               </a:rPr>
-              <a:t> (Anexo II).</a:t>
+              <a:t>·IAM·M (Anexo II).</a:t>
             </a:r>
           </a:p>
           <a:p>
@@ -29074,7 +29096,7 @@
               </a:lnSpc>
             </a:pPr>
             <a:r>
-              <a:rPr sz="1800">
+              <a:rPr sz="1600">
                 <a:solidFill>
                   <a:srgbClr val="FBFCFD"/>
                 </a:solidFill>
@@ -29082,7 +29104,7 @@
               <a:t>• </a:t>
             </a:r>
             <a:r>
-              <a:rPr sz="1800" b="1">
+              <a:rPr sz="1600" b="1">
                 <a:solidFill>
                   <a:srgbClr val="FBFCFD"/>
                 </a:solidFill>
@@ -29090,7 +29112,7 @@
               <a:t>Térmicas:</a:t>
             </a:r>
             <a:r>
-              <a:rPr sz="1800">
+              <a:rPr sz="1600">
                 <a:solidFill>
                   <a:srgbClr val="FBFCFD"/>
                 </a:solidFill>
@@ -29098,7 +29120,7 @@
               <a:t> caídas por elevada T</a:t>
             </a:r>
             <a:r>
-              <a:rPr sz="1400">
+              <a:rPr sz="1200">
                 <a:solidFill>
                   <a:srgbClr val="FBFCFD"/>
                 </a:solidFill>
@@ -29106,7 +29128,7 @@
               <a:t>c</a:t>
             </a:r>
             <a:r>
-              <a:rPr sz="1800">
+              <a:rPr sz="1600">
                 <a:solidFill>
                   <a:srgbClr val="FBFCFD"/>
                 </a:solidFill>
@@ -29121,7 +29143,7 @@
               </a:lnSpc>
             </a:pPr>
             <a:r>
-              <a:rPr sz="1800">
+              <a:rPr sz="1600">
                 <a:solidFill>
                   <a:srgbClr val="FBFCFD"/>
                 </a:solidFill>
@@ -29129,7 +29151,7 @@
               <a:t>• </a:t>
             </a:r>
             <a:r>
-              <a:rPr sz="1800" b="1">
+              <a:rPr sz="1600" b="1">
                 <a:solidFill>
                   <a:srgbClr val="FBFCFD"/>
                 </a:solidFill>
@@ -29137,7 +29159,7 @@
               <a:t>Óhmicas:</a:t>
             </a:r>
             <a:r>
-              <a:rPr sz="1800">
+              <a:rPr sz="1600">
                 <a:solidFill>
                   <a:srgbClr val="FBFCFD"/>
                 </a:solidFill>
@@ -29145,7 +29167,7 @@
               <a:t> pérdidas resistivas en R</a:t>
             </a:r>
             <a:r>
-              <a:rPr sz="1400">
+              <a:rPr sz="1200">
                 <a:solidFill>
                   <a:srgbClr val="FBFCFD"/>
                 </a:solidFill>
@@ -29153,7 +29175,7 @@
               <a:t>s</a:t>
             </a:r>
             <a:r>
-              <a:rPr sz="1800">
+              <a:rPr sz="1600">
                 <a:solidFill>
                   <a:srgbClr val="FBFCFD"/>
                 </a:solidFill>
@@ -29168,7 +29190,7 @@
               </a:lnSpc>
             </a:pPr>
             <a:r>
-              <a:rPr sz="1800">
+              <a:rPr sz="1600">
                 <a:solidFill>
                   <a:srgbClr val="FBFCFD"/>
                 </a:solidFill>
@@ -29176,7 +29198,7 @@
               <a:t>• </a:t>
             </a:r>
             <a:r>
-              <a:rPr sz="1800" b="1">
+              <a:rPr sz="1600" b="1">
                 <a:solidFill>
                   <a:srgbClr val="FBFCFD"/>
                 </a:solidFill>
@@ -29184,15 +29206,15 @@
               <a:t>De bajo G:</a:t>
             </a:r>
             <a:r>
-              <a:rPr sz="1800">
-                <a:solidFill>
-                  <a:srgbClr val="FBFCFD"/>
-                </a:solidFill>
-              </a:rPr>
-              <a:t> comportamiento no lineal a baja irradiancia (R</a:t>
-            </a:r>
-            <a:r>
-              <a:rPr sz="1400">
+              <a:rPr sz="1600">
+                <a:solidFill>
+                  <a:srgbClr val="FBFCFD"/>
+                </a:solidFill>
+              </a:rPr>
+              <a:t> no linealidad a baja irradiancia (R</a:t>
+            </a:r>
+            <a:r>
+              <a:rPr sz="1200">
                 <a:solidFill>
                   <a:srgbClr val="FBFCFD"/>
                 </a:solidFill>
@@ -29200,7 +29222,7 @@
               <a:t>sh</a:t>
             </a:r>
             <a:r>
-              <a:rPr sz="1800">
+              <a:rPr sz="1600">
                 <a:solidFill>
                   <a:srgbClr val="FBFCFD"/>
                 </a:solidFill>
@@ -29215,12 +29237,43 @@
               </a:lnSpc>
             </a:pPr>
             <a:r>
-              <a:rPr sz="1800">
-                <a:solidFill>
-                  <a:srgbClr val="FBFCFD"/>
-                </a:solidFill>
-              </a:rPr>
-              <a:t>• NO penaliza pérdidas ópticas/espectrales (no modeladas) ni de planta (cableado, inversor, soiling).</a:t>
+              <a:rPr sz="1600">
+                <a:solidFill>
+                  <a:srgbClr val="FBFCFD"/>
+                </a:solidFill>
+              </a:rPr>
+              <a:t>• </a:t>
+            </a:r>
+            <a:r>
+              <a:rPr sz="1600" b="1">
+                <a:solidFill>
+                  <a:srgbClr val="FBFCFD"/>
+                </a:solidFill>
+              </a:rPr>
+              <a:t>Ópticas/espectrales:</a:t>
+            </a:r>
+            <a:r>
+              <a:rPr sz="1600">
+                <a:solidFill>
+                  <a:srgbClr val="FBFCFD"/>
+                </a:solidFill>
+              </a:rPr>
+              <a:t> ahora penalizadas vía la irradiancia efectiva (IAM + factor espectral, ≈3 % en Atacama).</a:t>
+            </a:r>
+          </a:p>
+          <a:p>
+            <a:pPr algn="l">
+              <a:lnSpc>
+                <a:spcPct val="110000"/>
+              </a:lnSpc>
+            </a:pPr>
+            <a:r>
+              <a:rPr sz="1600">
+                <a:solidFill>
+                  <a:srgbClr val="FBFCFD"/>
+                </a:solidFill>
+              </a:rPr>
+              <a:t>• NO penaliza pérdidas de planta (cableado, inversor, soiling).</a:t>
             </a:r>
           </a:p>
         </p:txBody>
@@ -30066,6 +30119,23 @@
                 </a:solidFill>
                 <a:latin typeface="Consolas"/>
               </a:rPr>
+              <a:t>Relative humidity</a:t>
+            </a:r>
+            <a:r>
+              <a:rPr sz="1550">
+                <a:solidFill>
+                  <a:srgbClr val="FBFCFD"/>
+                </a:solidFill>
+              </a:rPr>
+              <a:t> (22), </a:t>
+            </a:r>
+            <a:r>
+              <a:rPr sz="1450">
+                <a:solidFill>
+                  <a:srgbClr val="7FDBFF"/>
+                </a:solidFill>
+                <a:latin typeface="Consolas"/>
+              </a:rPr>
               <a:t>Atmospheric pressure</a:t>
             </a:r>
             <a:r>
@@ -30140,7 +30210,7 @@
                   <a:srgbClr val="FBFCFD"/>
                 </a:solidFill>
               </a:rPr>
-              <a:t> (33) — c/u con incertidumbre y desv. estándar de muestras de 1 s.</a:t>
+              <a:t> (33) — c/u con incertidumbre.</a:t>
             </a:r>
           </a:p>
           <a:p>
@@ -30172,7 +30242,7 @@
                   <a:srgbClr val="FBFCFD"/>
                 </a:solidFill>
               </a:rPr>
-              <a:t> (1): referencia para verificar el recurso.</a:t>
+              <a:t> (1): referencia para verificar el recurso. Humedad+T+presión → factor espectral.</a:t>
             </a:r>
           </a:p>
         </p:txBody>
@@ -30381,7 +30451,7 @@
                   <a:srgbClr val="FBFCFD"/>
                 </a:solidFill>
               </a:rPr>
-              <a:t>, lluvia, humedad relativa, T dorso, T gabinete MT5, horarios de mantención (</a:t>
+              <a:t>, lluvia, T dorso, T gabinete MT5, horarios de mantención (</a:t>
             </a:r>
             <a:r>
               <a:rPr sz="1450">
@@ -32333,7 +32403,7 @@
                   <a:srgbClr val="FBFCFD"/>
                 </a:solidFill>
               </a:rPr>
-              <a:t> Mediana diaria suavizada (ventana 7 días) por archivo para aislar ruidos y nubes transitorias.</a:t>
+              <a:t> Mediana diaria (descartando días parciales con &lt;40 registros) suavizada a 7 días por archivo, para aislar ruidos, nubes transitorias y caídas del datalogger.</a:t>
             </a:r>
           </a:p>
         </p:txBody>
@@ -37176,7 +37246,7 @@
         </p:blipFill>
         <p:spPr>
           <a:xfrm>
-            <a:off x="380847" y="1097280"/>
+            <a:off x="380847" y="1554480"/>
             <a:ext cx="11430000" cy="2909454"/>
           </a:xfrm>
           <a:prstGeom prst="rect">

</xml_diff>

<commit_message>
fix: corrige desbordes de texto y simplifica explicacion de modificadores opticos
- Simplifica la vineta de modificadores opticos en la lamina de Marco Teorico
  (lenguaje simple, detalle tecnico remitido al Anexo II)
- Acorta titulo y pie de la lamina de modificadores opticos, moviendo el
  detalle de implementacion al Anexo II
- Corrige desborde de tabla en la lamina de Sintesis (chocaba con el pie de pagina)
- Corrige desborde de etiqueta y titulo en la lamina de Recurso Real
- Corrige desborde del panel de funciones pvlib en el Anexo de herramientas
- Ajusta alturas de panel en el Anexo XIII para evitar desborde
</commit_message>
<xml_diff>
--- a/output/Presentacion_Final_ELI556_Atacama_POA_Tarea2_revisado.pptx
+++ b/output/Presentacion_Final_ELI556_Atacama_POA_Tarea2_revisado.pptx
@@ -8173,7 +8173,7 @@
                   <a:srgbClr val="F1C40F"/>
                 </a:solidFill>
               </a:rPr>
-              <a:t>Procedimiento: Modificadores Ópticos APLICADOS — IAM y Espectral (Fase 2)</a:t>
+              <a:t>Procedimiento: Modificadores Ópticos (IAM y Espectral)</a:t>
             </a:r>
           </a:p>
         </p:txBody>
@@ -8376,7 +8376,7 @@
                   <a:srgbClr val="FBFCFD"/>
                 </a:solidFill>
               </a:rPr>
-              <a:t>Pérdidas ópticas y espectrales ahora ejecutadas en el pipeline:</a:t>
+              <a:t>¿Qué hacen?</a:t>
             </a:r>
             <a:r>
               <a:rPr sz="1550">
@@ -8384,7 +8384,7 @@
                   <a:srgbClr val="FBFCFD"/>
                 </a:solidFill>
               </a:rPr>
-              <a:t> sobre la POA de Perez (albedo </a:t>
+              <a:t> Sobre la POA de Perez (albedo </a:t>
             </a:r>
             <a:r>
               <a:rPr sz="1550" b="1">
@@ -8400,7 +8400,7 @@
                   <a:srgbClr val="FBFCFD"/>
                 </a:solidFill>
               </a:rPr>
-              <a:t>) se aplica el </a:t>
+              <a:t>) se descuentan dos pérdidas reales: el </a:t>
             </a:r>
             <a:r>
               <a:rPr sz="1550" b="1">
@@ -8408,7 +8408,7 @@
                   <a:srgbClr val="FBFCFD"/>
                 </a:solidFill>
               </a:rPr>
-              <a:t>IAM físico</a:t>
+              <a:t>IAM</a:t>
             </a:r>
             <a:r>
               <a:rPr sz="1550">
@@ -8416,7 +8416,71 @@
                   <a:srgbClr val="FBFCFD"/>
                 </a:solidFill>
               </a:rPr>
-              <a:t> de Snell-Bouguer (</a:t>
+              <a:t> quita la luz que se refleja en el vidrio cuando el sol llega muy inclinado (ángulos rasantes), y el </a:t>
+            </a:r>
+            <a:r>
+              <a:rPr sz="1550" b="1">
+                <a:solidFill>
+                  <a:srgbClr val="FBFCFD"/>
+                </a:solidFill>
+              </a:rPr>
+              <a:t>factor espectral</a:t>
+            </a:r>
+            <a:r>
+              <a:rPr sz="1550">
+                <a:solidFill>
+                  <a:srgbClr val="FBFCFD"/>
+                </a:solidFill>
+              </a:rPr>
+              <a:t> ajusta según el color de la luz solar. El resultado es la </a:t>
+            </a:r>
+            <a:r>
+              <a:rPr sz="1550" b="1">
+                <a:solidFill>
+                  <a:srgbClr val="FBFCFD"/>
+                </a:solidFill>
+              </a:rPr>
+              <a:t>irradiancia efectiva</a:t>
+            </a:r>
+            <a:r>
+              <a:rPr sz="1550">
+                <a:solidFill>
+                  <a:srgbClr val="FBFCFD"/>
+                </a:solidFill>
+              </a:rPr>
+              <a:t> que realmente genera corriente en la Fase 4. Efecto en Atacama: pérdida óptica ≈ </a:t>
+            </a:r>
+            <a:r>
+              <a:rPr sz="1550" b="1">
+                <a:solidFill>
+                  <a:srgbClr val="FBFCFD"/>
+                </a:solidFill>
+              </a:rPr>
+              <a:t>3.0 %</a:t>
+            </a:r>
+            <a:r>
+              <a:rPr sz="1550">
+                <a:solidFill>
+                  <a:srgbClr val="FBFCFD"/>
+                </a:solidFill>
+              </a:rPr>
+              <a:t> y espectral ≈ </a:t>
+            </a:r>
+            <a:r>
+              <a:rPr sz="1550" b="1">
+                <a:solidFill>
+                  <a:srgbClr val="FBFCFD"/>
+                </a:solidFill>
+              </a:rPr>
+              <a:t>neutra</a:t>
+            </a:r>
+            <a:r>
+              <a:rPr sz="1550">
+                <a:solidFill>
+                  <a:srgbClr val="FBFCFD"/>
+                </a:solidFill>
+              </a:rPr>
+              <a:t> (cielo seco y limpio). Ecuaciones, constantes y funciones </a:t>
             </a:r>
             <a:r>
               <a:rPr sz="1450">
@@ -8425,7 +8489,7 @@
                 </a:solidFill>
                 <a:latin typeface="Consolas"/>
               </a:rPr>
-              <a:t>pvlib.iam.physical</a:t>
+              <a:t>pvlib</a:t>
             </a:r>
             <a:r>
               <a:rPr sz="1550">
@@ -8433,104 +8497,7 @@
                   <a:srgbClr val="FBFCFD"/>
                 </a:solidFill>
               </a:rPr>
-              <a:t>, n=1.526, K=4 m⁻¹, L=2 mm) a la directa y los factores de Marion a la difusa, y el </a:t>
-            </a:r>
-            <a:r>
-              <a:rPr sz="1550" b="1">
-                <a:solidFill>
-                  <a:srgbClr val="FBFCFD"/>
-                </a:solidFill>
-              </a:rPr>
-              <a:t>factor espectral</a:t>
-            </a:r>
-            <a:r>
-              <a:rPr sz="1550">
-                <a:solidFill>
-                  <a:srgbClr val="FBFCFD"/>
-                </a:solidFill>
-              </a:rPr>
-              <a:t> First Solar (</a:t>
-            </a:r>
-            <a:r>
-              <a:rPr sz="1450">
-                <a:solidFill>
-                  <a:srgbClr val="7FDBFF"/>
-                </a:solidFill>
-                <a:latin typeface="Consolas"/>
-              </a:rPr>
-              <a:t>spectral_factor_firstsolar</a:t>
-            </a:r>
-            <a:r>
-              <a:rPr sz="1550">
-                <a:solidFill>
-                  <a:srgbClr val="FBFCFD"/>
-                </a:solidFill>
-              </a:rPr>
-              <a:t>, agua precipitable + masa de aire). El resultado es la </a:t>
-            </a:r>
-            <a:r>
-              <a:rPr sz="1550" b="1">
-                <a:solidFill>
-                  <a:srgbClr val="FBFCFD"/>
-                </a:solidFill>
-              </a:rPr>
-              <a:t>irradiancia efectiva</a:t>
-            </a:r>
-            <a:r>
-              <a:rPr sz="1550">
-                <a:solidFill>
-                  <a:srgbClr val="FBFCFD"/>
-                </a:solidFill>
-              </a:rPr>
-              <a:t> que fotogenera I</a:t>
-            </a:r>
-            <a:r>
-              <a:rPr sz="1150">
-                <a:solidFill>
-                  <a:srgbClr val="FBFCFD"/>
-                </a:solidFill>
-              </a:rPr>
-              <a:t>L</a:t>
-            </a:r>
-            <a:r>
-              <a:rPr sz="1550">
-                <a:solidFill>
-                  <a:srgbClr val="FBFCFD"/>
-                </a:solidFill>
-              </a:rPr>
-              <a:t> en la Fase 4. Efecto en Atacama: pérdida óptica ≈ </a:t>
-            </a:r>
-            <a:r>
-              <a:rPr sz="1550" b="1">
-                <a:solidFill>
-                  <a:srgbClr val="FBFCFD"/>
-                </a:solidFill>
-              </a:rPr>
-              <a:t>3.0 %</a:t>
-            </a:r>
-            <a:r>
-              <a:rPr sz="1550">
-                <a:solidFill>
-                  <a:srgbClr val="FBFCFD"/>
-                </a:solidFill>
-              </a:rPr>
-              <a:t> (ángulos rasantes) y espectral ≈ </a:t>
-            </a:r>
-            <a:r>
-              <a:rPr sz="1550" b="1">
-                <a:solidFill>
-                  <a:srgbClr val="FBFCFD"/>
-                </a:solidFill>
-              </a:rPr>
-              <a:t>neutra</a:t>
-            </a:r>
-            <a:r>
-              <a:rPr sz="1550">
-                <a:solidFill>
-                  <a:srgbClr val="FBFCFD"/>
-                </a:solidFill>
-              </a:rPr>
-              <a:t> (cielo seco y limpio) — ecuaciones en (Anexo II, Lám. 29).</a:t>
+              <a:t> en (Anexo II, Lám. 29).</a:t>
             </a:r>
           </a:p>
         </p:txBody>
@@ -15659,7 +15626,7 @@
                   <a:srgbClr val="F1C40F"/>
                 </a:solidFill>
               </a:rPr>
-              <a:t>Resultado: Recurso REAL de Atacama (PVGIS TMY) — Magnitudes Absolutas</a:t>
+              <a:t>Resultado: Recurso REAL de Atacama (PVGIS TMY)</a:t>
             </a:r>
           </a:p>
         </p:txBody>
@@ -16003,7 +15970,7 @@
                   <a:srgbClr val="9AA5B1"/>
                 </a:solidFill>
               </a:rPr>
-              <a:t>(kWh/m²·año, albedo 0.20)</a:t>
+              <a:t>(kWh/m²·año)</a:t>
             </a:r>
           </a:p>
         </p:txBody>
@@ -17001,7 +16968,7 @@
         </p:nvGraphicFramePr>
         <p:xfrm>
           <a:off x="594360" y="1737360"/>
-          <a:ext cx="11002972" cy="4434840"/>
+          <a:ext cx="11002972" cy="4160520"/>
         </p:xfrm>
         <a:graphic>
           <a:graphicData uri="http://schemas.openxmlformats.org/drawingml/2006/table">
@@ -17015,7 +16982,7 @@
                 <a:gridCol w="2089172"/>
                 <a:gridCol w="2367728"/>
               </a:tblGrid>
-              <a:tr h="633548">
+              <a:tr h="594360">
                 <a:tc>
                   <a:txBody>
                     <a:bodyPr wrap="square" lIns="54864" rIns="54864" tIns="36576" bIns="36576"/>
@@ -17023,7 +16990,7 @@
                     <a:p>
                       <a:pPr algn="ctr"/>
                       <a:r>
-                        <a:rPr sz="1500" b="1">
+                        <a:rPr sz="1400" b="1">
                           <a:solidFill>
                             <a:srgbClr val="F1C40F"/>
                           </a:solidFill>
@@ -17045,7 +17012,7 @@
                     <a:p>
                       <a:pPr algn="ctr"/>
                       <a:r>
-                        <a:rPr sz="1500" b="1">
+                        <a:rPr sz="1400" b="1">
                           <a:solidFill>
                             <a:srgbClr val="F1C40F"/>
                           </a:solidFill>
@@ -17067,7 +17034,7 @@
                     <a:p>
                       <a:pPr algn="ctr"/>
                       <a:r>
-                        <a:rPr sz="1500" b="1">
+                        <a:rPr sz="1400" b="1">
                           <a:solidFill>
                             <a:srgbClr val="F1C40F"/>
                           </a:solidFill>
@@ -17089,7 +17056,7 @@
                     <a:p>
                       <a:pPr algn="ctr"/>
                       <a:r>
-                        <a:rPr sz="1500" b="1">
+                        <a:rPr sz="1400" b="1">
                           <a:solidFill>
                             <a:srgbClr val="F1C40F"/>
                           </a:solidFill>
@@ -17105,7 +17072,7 @@
                   </a:tcPr>
                 </a:tc>
               </a:tr>
-              <a:tr h="633548">
+              <a:tr h="594360">
                 <a:tc>
                   <a:txBody>
                     <a:bodyPr wrap="square" lIns="54864" rIns="54864" tIns="36576" bIns="36576"/>
@@ -17113,7 +17080,7 @@
                     <a:p>
                       <a:pPr algn="l"/>
                       <a:r>
-                        <a:rPr sz="1350">
+                        <a:rPr sz="1250">
                           <a:solidFill>
                             <a:srgbClr val="FBFCFD"/>
                           </a:solidFill>
@@ -17121,7 +17088,7 @@
                         <a:t>Recurso solar: G</a:t>
                       </a:r>
                       <a:r>
-                        <a:rPr sz="950">
+                        <a:rPr sz="850">
                           <a:solidFill>
                             <a:srgbClr val="FBFCFD"/>
                           </a:solidFill>
@@ -17129,7 +17096,7 @@
                         <a:t>poa</a:t>
                       </a:r>
                       <a:r>
-                        <a:rPr sz="1350">
+                        <a:rPr sz="1250">
                           <a:solidFill>
                             <a:srgbClr val="FBFCFD"/>
                           </a:solidFill>
@@ -17151,7 +17118,7 @@
                     <a:p>
                       <a:pPr algn="ctr"/>
                       <a:r>
-                        <a:rPr sz="1350">
+                        <a:rPr sz="1250">
                           <a:solidFill>
                             <a:srgbClr val="FBFCFD"/>
                           </a:solidFill>
@@ -17173,7 +17140,7 @@
                     <a:p>
                       <a:pPr algn="ctr"/>
                       <a:r>
-                        <a:rPr sz="1350">
+                        <a:rPr sz="1250">
                           <a:solidFill>
                             <a:srgbClr val="FBFCFD"/>
                           </a:solidFill>
@@ -17195,7 +17162,7 @@
                     <a:p>
                       <a:pPr algn="ctr"/>
                       <a:r>
-                        <a:rPr sz="1350">
+                        <a:rPr sz="1250">
                           <a:solidFill>
                             <a:srgbClr val="FBFCFD"/>
                           </a:solidFill>
@@ -17211,7 +17178,7 @@
                   </a:tcPr>
                 </a:tc>
               </a:tr>
-              <a:tr h="633548">
+              <a:tr h="594360">
                 <a:tc>
                   <a:txBody>
                     <a:bodyPr wrap="square" lIns="54864" rIns="54864" tIns="36576" bIns="36576"/>
@@ -17219,7 +17186,7 @@
                     <a:p>
                       <a:pPr algn="l"/>
                       <a:r>
-                        <a:rPr sz="1350">
+                        <a:rPr sz="1250">
                           <a:solidFill>
                             <a:srgbClr val="FBFCFD"/>
                           </a:solidFill>
@@ -17227,7 +17194,7 @@
                         <a:t>Perfil térmico T</a:t>
                       </a:r>
                       <a:r>
-                        <a:rPr sz="950">
+                        <a:rPr sz="850">
                           <a:solidFill>
                             <a:srgbClr val="FBFCFD"/>
                           </a:solidFill>
@@ -17235,7 +17202,7 @@
                         <a:t>c</a:t>
                       </a:r>
                       <a:r>
-                        <a:rPr sz="1350">
+                        <a:rPr sz="1250">
                           <a:solidFill>
                             <a:srgbClr val="FBFCFD"/>
                           </a:solidFill>
@@ -17257,7 +17224,7 @@
                     <a:p>
                       <a:pPr algn="ctr"/>
                       <a:r>
-                        <a:rPr sz="1350">
+                        <a:rPr sz="1250">
                           <a:solidFill>
                             <a:srgbClr val="FBFCFD"/>
                           </a:solidFill>
@@ -17279,7 +17246,7 @@
                     <a:p>
                       <a:pPr algn="ctr"/>
                       <a:r>
-                        <a:rPr sz="1350">
+                        <a:rPr sz="1250">
                           <a:solidFill>
                             <a:srgbClr val="FBFCFD"/>
                           </a:solidFill>
@@ -17301,7 +17268,7 @@
                     <a:p>
                       <a:pPr algn="ctr"/>
                       <a:r>
-                        <a:rPr sz="1350">
+                        <a:rPr sz="1250">
                           <a:solidFill>
                             <a:srgbClr val="FBFCFD"/>
                           </a:solidFill>
@@ -17309,7 +17276,7 @@
                         <a:t>T</a:t>
                       </a:r>
                       <a:r>
-                        <a:rPr sz="950">
+                        <a:rPr sz="850">
                           <a:solidFill>
                             <a:srgbClr val="FBFCFD"/>
                           </a:solidFill>
@@ -17317,7 +17284,7 @@
                         <a:t>c</a:t>
                       </a:r>
                       <a:r>
-                        <a:rPr sz="1350">
+                        <a:rPr sz="1250">
                           <a:solidFill>
                             <a:srgbClr val="FBFCFD"/>
                           </a:solidFill>
@@ -17333,7 +17300,7 @@
                   </a:tcPr>
                 </a:tc>
               </a:tr>
-              <a:tr h="633548">
+              <a:tr h="594360">
                 <a:tc>
                   <a:txBody>
                     <a:bodyPr wrap="square" lIns="54864" rIns="54864" tIns="36576" bIns="36576"/>
@@ -17341,7 +17308,7 @@
                     <a:p>
                       <a:pPr algn="l"/>
                       <a:r>
-                        <a:rPr sz="1350">
+                        <a:rPr sz="1250">
                           <a:solidFill>
                             <a:srgbClr val="FBFCFD"/>
                           </a:solidFill>
@@ -17363,7 +17330,7 @@
                     <a:p>
                       <a:pPr algn="ctr"/>
                       <a:r>
-                        <a:rPr sz="1250">
+                        <a:rPr sz="1150">
                           <a:solidFill>
                             <a:srgbClr val="7FDBFF"/>
                           </a:solidFill>
@@ -17372,7 +17339,7 @@
                         <a:t>minimize</a:t>
                       </a:r>
                       <a:r>
-                        <a:rPr sz="1350">
+                        <a:rPr sz="1250">
                           <a:solidFill>
                             <a:srgbClr val="FBFCFD"/>
                           </a:solidFill>
@@ -17394,7 +17361,7 @@
                     <a:p>
                       <a:pPr algn="ctr"/>
                       <a:r>
-                        <a:rPr sz="1350">
+                        <a:rPr sz="1250">
                           <a:solidFill>
                             <a:srgbClr val="FBFCFD"/>
                           </a:solidFill>
@@ -17416,7 +17383,7 @@
                     <a:p>
                       <a:pPr algn="ctr"/>
                       <a:r>
-                        <a:rPr sz="1350">
+                        <a:rPr sz="1250">
                           <a:solidFill>
                             <a:srgbClr val="FBFCFD"/>
                           </a:solidFill>
@@ -17432,7 +17399,7 @@
                   </a:tcPr>
                 </a:tc>
               </a:tr>
-              <a:tr h="633548">
+              <a:tr h="594360">
                 <a:tc>
                   <a:txBody>
                     <a:bodyPr wrap="square" lIns="54864" rIns="54864" tIns="36576" bIns="36576"/>
@@ -17440,7 +17407,7 @@
                     <a:p>
                       <a:pPr algn="l"/>
                       <a:r>
-                        <a:rPr sz="1350">
+                        <a:rPr sz="1250">
                           <a:solidFill>
                             <a:srgbClr val="FBFCFD"/>
                           </a:solidFill>
@@ -17448,7 +17415,7 @@
                         <a:t>Discusión R</a:t>
                       </a:r>
                       <a:r>
-                        <a:rPr sz="950">
+                        <a:rPr sz="850">
                           <a:solidFill>
                             <a:srgbClr val="FBFCFD"/>
                           </a:solidFill>
@@ -17456,7 +17423,7 @@
                         <a:t>s</a:t>
                       </a:r>
                       <a:r>
-                        <a:rPr sz="1350">
+                        <a:rPr sz="1250">
                           <a:solidFill>
                             <a:srgbClr val="FBFCFD"/>
                           </a:solidFill>
@@ -17478,7 +17445,7 @@
                     <a:p>
                       <a:pPr algn="ctr"/>
                       <a:r>
-                        <a:rPr sz="1350">
+                        <a:rPr sz="1250">
                           <a:solidFill>
                             <a:srgbClr val="FBFCFD"/>
                           </a:solidFill>
@@ -17500,7 +17467,7 @@
                     <a:p>
                       <a:pPr algn="ctr"/>
                       <a:r>
-                        <a:rPr sz="1350">
+                        <a:rPr sz="1250">
                           <a:solidFill>
                             <a:srgbClr val="FBFCFD"/>
                           </a:solidFill>
@@ -17522,7 +17489,7 @@
                     <a:p>
                       <a:pPr algn="ctr"/>
                       <a:r>
-                        <a:rPr sz="1350">
+                        <a:rPr sz="1250">
                           <a:solidFill>
                             <a:srgbClr val="FBFCFD"/>
                           </a:solidFill>
@@ -17530,7 +17497,7 @@
                         <a:t>n</a:t>
                       </a:r>
                       <a:r>
-                        <a:rPr sz="950">
+                        <a:rPr sz="850">
                           <a:solidFill>
                             <a:srgbClr val="FBFCFD"/>
                           </a:solidFill>
@@ -17538,7 +17505,7 @@
                         <a:t>I</a:t>
                       </a:r>
                       <a:r>
-                        <a:rPr sz="1350">
+                        <a:rPr sz="1250">
                           <a:solidFill>
                             <a:srgbClr val="FBFCFD"/>
                           </a:solidFill>
@@ -17554,7 +17521,7 @@
                   </a:tcPr>
                 </a:tc>
               </a:tr>
-              <a:tr h="633548">
+              <a:tr h="594360">
                 <a:tc>
                   <a:txBody>
                     <a:bodyPr wrap="square" lIns="54864" rIns="54864" tIns="36576" bIns="36576"/>
@@ -17562,7 +17529,7 @@
                     <a:p>
                       <a:pPr algn="l"/>
                       <a:r>
-                        <a:rPr sz="1350">
+                        <a:rPr sz="1250">
                           <a:solidFill>
                             <a:srgbClr val="FBFCFD"/>
                           </a:solidFill>
@@ -17584,7 +17551,7 @@
                     <a:p>
                       <a:pPr algn="ctr"/>
                       <a:r>
-                        <a:rPr sz="1350">
+                        <a:rPr sz="1250">
                           <a:solidFill>
                             <a:srgbClr val="FBFCFD"/>
                           </a:solidFill>
@@ -17592,7 +17559,7 @@
                         <a:t>Σ P</a:t>
                       </a:r>
                       <a:r>
-                        <a:rPr sz="950">
+                        <a:rPr sz="850">
                           <a:solidFill>
                             <a:srgbClr val="FBFCFD"/>
                           </a:solidFill>
@@ -17600,7 +17567,7 @@
                         <a:t>mp</a:t>
                       </a:r>
                       <a:r>
-                        <a:rPr sz="1350">
+                        <a:rPr sz="1250">
                           <a:solidFill>
                             <a:srgbClr val="FBFCFD"/>
                           </a:solidFill>
@@ -17608,7 +17575,7 @@
                         <a:t> / Σ P</a:t>
                       </a:r>
                       <a:r>
-                        <a:rPr sz="950">
+                        <a:rPr sz="850">
                           <a:solidFill>
                             <a:srgbClr val="FBFCFD"/>
                           </a:solidFill>
@@ -17616,7 +17583,7 @@
                         <a:t>STC</a:t>
                       </a:r>
                       <a:r>
-                        <a:rPr sz="1350">
+                        <a:rPr sz="1250">
                           <a:solidFill>
                             <a:srgbClr val="FBFCFD"/>
                           </a:solidFill>
@@ -17638,7 +17605,7 @@
                     <a:p>
                       <a:pPr algn="ctr"/>
                       <a:r>
-                        <a:rPr sz="1350">
+                        <a:rPr sz="1250">
                           <a:solidFill>
                             <a:srgbClr val="FBFCFD"/>
                           </a:solidFill>
@@ -17660,7 +17627,7 @@
                     <a:p>
                       <a:pPr algn="ctr"/>
                       <a:r>
-                        <a:rPr sz="1350">
+                        <a:rPr sz="1250">
                           <a:solidFill>
                             <a:srgbClr val="FBFCFD"/>
                           </a:solidFill>
@@ -17676,7 +17643,7 @@
                   </a:tcPr>
                 </a:tc>
               </a:tr>
-              <a:tr h="633552">
+              <a:tr h="594360">
                 <a:tc>
                   <a:txBody>
                     <a:bodyPr wrap="square" lIns="54864" rIns="54864" tIns="36576" bIns="36576"/>
@@ -17684,7 +17651,7 @@
                     <a:p>
                       <a:pPr algn="l"/>
                       <a:r>
-                        <a:rPr sz="1350">
+                        <a:rPr sz="1250">
                           <a:solidFill>
                             <a:srgbClr val="FBFCFD"/>
                           </a:solidFill>
@@ -17706,7 +17673,7 @@
                     <a:p>
                       <a:pPr algn="ctr"/>
                       <a:r>
-                        <a:rPr sz="1350">
+                        <a:rPr sz="1250">
                           <a:solidFill>
                             <a:srgbClr val="FBFCFD"/>
                           </a:solidFill>
@@ -17728,7 +17695,7 @@
                     <a:p>
                       <a:pPr algn="ctr"/>
                       <a:r>
-                        <a:rPr sz="1350">
+                        <a:rPr sz="1250">
                           <a:solidFill>
                             <a:srgbClr val="FBFCFD"/>
                           </a:solidFill>
@@ -17750,7 +17717,7 @@
                     <a:p>
                       <a:pPr algn="ctr"/>
                       <a:r>
-                        <a:rPr sz="1350">
+                        <a:rPr sz="1250">
                           <a:solidFill>
                             <a:srgbClr val="FBFCFD"/>
                           </a:solidFill>
@@ -20087,7 +20054,7 @@
         <p:spPr>
           <a:xfrm>
             <a:off x="365760" y="1188720"/>
-            <a:ext cx="5592927" cy="2395728"/>
+            <a:ext cx="5592927" cy="2194560"/>
           </a:xfrm>
           <a:prstGeom prst="rect">
             <a:avLst/>
@@ -20132,7 +20099,7 @@
         <p:spPr>
           <a:xfrm>
             <a:off x="365760" y="1188720"/>
-            <a:ext cx="73152" cy="2395728"/>
+            <a:ext cx="73152" cy="2194560"/>
           </a:xfrm>
           <a:prstGeom prst="rect">
             <a:avLst/>
@@ -20209,7 +20176,7 @@
         <p:spPr>
           <a:xfrm>
             <a:off x="566928" y="1828800"/>
-            <a:ext cx="5190591" cy="1591056"/>
+            <a:ext cx="5190591" cy="1389888"/>
           </a:xfrm>
           <a:prstGeom prst="rect">
             <a:avLst/>
@@ -20224,11 +20191,11 @@
           <a:p>
             <a:pPr algn="l">
               <a:lnSpc>
-                <a:spcPct val="106000"/>
+                <a:spcPct val="105000"/>
               </a:lnSpc>
             </a:pPr>
             <a:r>
-              <a:rPr sz="1400">
+              <a:rPr sz="1300">
                 <a:solidFill>
                   <a:srgbClr val="FBFCFD"/>
                 </a:solidFill>
@@ -20236,7 +20203,7 @@
               <a:t>• </a:t>
             </a:r>
             <a:r>
-              <a:rPr sz="1400" b="1">
+              <a:rPr sz="1300" b="1">
                 <a:solidFill>
                   <a:srgbClr val="FBFCFD"/>
                 </a:solidFill>
@@ -20244,7 +20211,7 @@
               <a:t>Python 3.12</a:t>
             </a:r>
             <a:r>
-              <a:rPr sz="1400">
+              <a:rPr sz="1300">
                 <a:solidFill>
                   <a:srgbClr val="FBFCFD"/>
                 </a:solidFill>
@@ -20252,16 +20219,16 @@
               <a:t> en entorno virtual (</a:t>
             </a:r>
             <a:r>
+              <a:rPr sz="1200">
+                <a:solidFill>
+                  <a:srgbClr val="7FDBFF"/>
+                </a:solidFill>
+                <a:latin typeface="Consolas"/>
+              </a:rPr>
+              <a:t>venv</a:t>
+            </a:r>
+            <a:r>
               <a:rPr sz="1300">
-                <a:solidFill>
-                  <a:srgbClr val="7FDBFF"/>
-                </a:solidFill>
-                <a:latin typeface="Consolas"/>
-              </a:rPr>
-              <a:t>venv</a:t>
-            </a:r>
-            <a:r>
-              <a:rPr sz="1400">
                 <a:solidFill>
                   <a:srgbClr val="FBFCFD"/>
                 </a:solidFill>
@@ -20272,11 +20239,11 @@
           <a:p>
             <a:pPr algn="l">
               <a:lnSpc>
-                <a:spcPct val="106000"/>
+                <a:spcPct val="105000"/>
               </a:lnSpc>
             </a:pPr>
             <a:r>
-              <a:rPr sz="1400">
+              <a:rPr sz="1300">
                 <a:solidFill>
                   <a:srgbClr val="FBFCFD"/>
                 </a:solidFill>
@@ -20284,7 +20251,7 @@
               <a:t>• </a:t>
             </a:r>
             <a:r>
-              <a:rPr sz="1400" b="1">
+              <a:rPr sz="1300" b="1">
                 <a:solidFill>
                   <a:srgbClr val="FBFCFD"/>
                 </a:solidFill>
@@ -20292,22 +20259,22 @@
               <a:t>pvlib 0.15</a:t>
             </a:r>
             <a:r>
-              <a:rPr sz="1400">
-                <a:solidFill>
-                  <a:srgbClr val="FBFCFD"/>
-                </a:solidFill>
-              </a:rPr>
-              <a:t> — modelado fotovoltaico (transposición, IAM, espectral, térmico, modelo de diodo, lectura PVGIS).</a:t>
+              <a:rPr sz="1300">
+                <a:solidFill>
+                  <a:srgbClr val="FBFCFD"/>
+                </a:solidFill>
+              </a:rPr>
+              <a:t> — modelado fotovoltaico (transposición, IAM, espectral, térmico, diodo, lectura PVGIS).</a:t>
             </a:r>
           </a:p>
           <a:p>
             <a:pPr algn="l">
               <a:lnSpc>
-                <a:spcPct val="106000"/>
+                <a:spcPct val="105000"/>
               </a:lnSpc>
             </a:pPr>
             <a:r>
-              <a:rPr sz="1400">
+              <a:rPr sz="1300">
                 <a:solidFill>
                   <a:srgbClr val="FBFCFD"/>
                 </a:solidFill>
@@ -20315,7 +20282,7 @@
               <a:t>• </a:t>
             </a:r>
             <a:r>
-              <a:rPr sz="1400" b="1">
+              <a:rPr sz="1300" b="1">
                 <a:solidFill>
                   <a:srgbClr val="FBFCFD"/>
                 </a:solidFill>
@@ -20323,7 +20290,7 @@
               <a:t>NumPy 2.4</a:t>
             </a:r>
             <a:r>
-              <a:rPr sz="1400">
+              <a:rPr sz="1300">
                 <a:solidFill>
                   <a:srgbClr val="FBFCFD"/>
                 </a:solidFill>
@@ -20334,11 +20301,11 @@
           <a:p>
             <a:pPr algn="l">
               <a:lnSpc>
-                <a:spcPct val="106000"/>
+                <a:spcPct val="105000"/>
               </a:lnSpc>
             </a:pPr>
             <a:r>
-              <a:rPr sz="1400">
+              <a:rPr sz="1300">
                 <a:solidFill>
                   <a:srgbClr val="FBFCFD"/>
                 </a:solidFill>
@@ -20346,7 +20313,7 @@
               <a:t>• </a:t>
             </a:r>
             <a:r>
-              <a:rPr sz="1400" b="1">
+              <a:rPr sz="1300" b="1">
                 <a:solidFill>
                   <a:srgbClr val="FBFCFD"/>
                 </a:solidFill>
@@ -20354,7 +20321,7 @@
               <a:t>pandas 3.0</a:t>
             </a:r>
             <a:r>
-              <a:rPr sz="1400">
+              <a:rPr sz="1300">
                 <a:solidFill>
                   <a:srgbClr val="FBFCFD"/>
                 </a:solidFill>
@@ -20362,16 +20329,16 @@
               <a:t> — series temporales, </a:t>
             </a:r>
             <a:r>
+              <a:rPr sz="1200">
+                <a:solidFill>
+                  <a:srgbClr val="7FDBFF"/>
+                </a:solidFill>
+                <a:latin typeface="Consolas"/>
+              </a:rPr>
+              <a:t>resample</a:t>
+            </a:r>
+            <a:r>
               <a:rPr sz="1300">
-                <a:solidFill>
-                  <a:srgbClr val="7FDBFF"/>
-                </a:solidFill>
-                <a:latin typeface="Consolas"/>
-              </a:rPr>
-              <a:t>resample</a:t>
-            </a:r>
-            <a:r>
-              <a:rPr sz="1400">
                 <a:solidFill>
                   <a:srgbClr val="FBFCFD"/>
                 </a:solidFill>
@@ -20382,11 +20349,11 @@
           <a:p>
             <a:pPr algn="l">
               <a:lnSpc>
-                <a:spcPct val="106000"/>
+                <a:spcPct val="105000"/>
               </a:lnSpc>
             </a:pPr>
             <a:r>
-              <a:rPr sz="1400">
+              <a:rPr sz="1300">
                 <a:solidFill>
                   <a:srgbClr val="FBFCFD"/>
                 </a:solidFill>
@@ -20394,7 +20361,7 @@
               <a:t>• </a:t>
             </a:r>
             <a:r>
-              <a:rPr sz="1400" b="1">
+              <a:rPr sz="1300" b="1">
                 <a:solidFill>
                   <a:srgbClr val="FBFCFD"/>
                 </a:solidFill>
@@ -20402,7 +20369,7 @@
               <a:t>SciPy</a:t>
             </a:r>
             <a:r>
-              <a:rPr sz="1400">
+              <a:rPr sz="1300">
                 <a:solidFill>
                   <a:srgbClr val="FBFCFD"/>
                 </a:solidFill>
@@ -20410,38 +20377,38 @@
               <a:t> — </a:t>
             </a:r>
             <a:r>
+              <a:rPr sz="1200">
+                <a:solidFill>
+                  <a:srgbClr val="7FDBFF"/>
+                </a:solidFill>
+                <a:latin typeface="Consolas"/>
+              </a:rPr>
+              <a:t>optimize.minimize</a:t>
+            </a:r>
+            <a:r>
               <a:rPr sz="1300">
                 <a:solidFill>
+                  <a:srgbClr val="FBFCFD"/>
+                </a:solidFill>
+              </a:rPr>
+              <a:t>/</a:t>
+            </a:r>
+            <a:r>
+              <a:rPr sz="1200">
+                <a:solidFill>
                   <a:srgbClr val="7FDBFF"/>
                 </a:solidFill>
                 <a:latin typeface="Consolas"/>
               </a:rPr>
-              <a:t>optimize.minimize</a:t>
-            </a:r>
-            <a:r>
-              <a:rPr sz="1400">
-                <a:solidFill>
-                  <a:srgbClr val="FBFCFD"/>
-                </a:solidFill>
-              </a:rPr>
-              <a:t>/</a:t>
+              <a:t>fsolve</a:t>
             </a:r>
             <a:r>
               <a:rPr sz="1300">
                 <a:solidFill>
-                  <a:srgbClr val="7FDBFF"/>
-                </a:solidFill>
-                <a:latin typeface="Consolas"/>
-              </a:rPr>
-              <a:t>fsolve</a:t>
-            </a:r>
-            <a:r>
-              <a:rPr sz="1400">
-                <a:solidFill>
-                  <a:srgbClr val="FBFCFD"/>
-                </a:solidFill>
-              </a:rPr>
-              <a:t> (ajuste de 5 parámetros).</a:t>
+                  <a:srgbClr val="FBFCFD"/>
+                </a:solidFill>
+              </a:rPr>
+              <a:t> (5 parámetros).</a:t>
             </a:r>
           </a:p>
         </p:txBody>
@@ -20454,8 +20421,8 @@
         </p:nvSpPr>
         <p:spPr>
           <a:xfrm>
-            <a:off x="365760" y="3785616"/>
-            <a:ext cx="5592927" cy="2395728"/>
+            <a:off x="365760" y="3584448"/>
+            <a:ext cx="5592927" cy="2724912"/>
           </a:xfrm>
           <a:prstGeom prst="rect">
             <a:avLst/>
@@ -20499,8 +20466,8 @@
         </p:nvSpPr>
         <p:spPr>
           <a:xfrm>
-            <a:off x="365760" y="3785616"/>
-            <a:ext cx="73152" cy="2395728"/>
+            <a:off x="365760" y="3584448"/>
+            <a:ext cx="73152" cy="2724912"/>
           </a:xfrm>
           <a:prstGeom prst="rect">
             <a:avLst/>
@@ -20542,7 +20509,7 @@
         </p:nvSpPr>
         <p:spPr>
           <a:xfrm>
-            <a:off x="530352" y="3877056"/>
+            <a:off x="530352" y="3675888"/>
             <a:ext cx="5318607" cy="411480"/>
           </a:xfrm>
           <a:prstGeom prst="rect">
@@ -20576,8 +20543,8 @@
         </p:nvSpPr>
         <p:spPr>
           <a:xfrm>
-            <a:off x="566928" y="4425696"/>
-            <a:ext cx="5190591" cy="1591056"/>
+            <a:off x="566928" y="4224528"/>
+            <a:ext cx="5190591" cy="1920240"/>
           </a:xfrm>
           <a:prstGeom prst="rect">
             <a:avLst/>
@@ -20592,11 +20559,11 @@
           <a:p>
             <a:pPr algn="l">
               <a:lnSpc>
-                <a:spcPct val="106000"/>
+                <a:spcPct val="105000"/>
               </a:lnSpc>
             </a:pPr>
             <a:r>
-              <a:rPr sz="1400">
+              <a:rPr sz="1300">
                 <a:solidFill>
                   <a:srgbClr val="FBFCFD"/>
                 </a:solidFill>
@@ -20604,50 +20571,50 @@
               <a:t>• </a:t>
             </a:r>
             <a:r>
+              <a:rPr sz="1200">
+                <a:solidFill>
+                  <a:srgbClr val="7FDBFF"/>
+                </a:solidFill>
+                <a:latin typeface="Consolas"/>
+              </a:rPr>
+              <a:t>get_total_irradiance</a:t>
+            </a:r>
+            <a:r>
               <a:rPr sz="1300">
                 <a:solidFill>
+                  <a:srgbClr val="FBFCFD"/>
+                </a:solidFill>
+              </a:rPr>
+              <a:t> (Perez), </a:t>
+            </a:r>
+            <a:r>
+              <a:rPr sz="1200">
+                <a:solidFill>
                   <a:srgbClr val="7FDBFF"/>
                 </a:solidFill>
                 <a:latin typeface="Consolas"/>
               </a:rPr>
-              <a:t>irradiance.get_total_irradiance</a:t>
-            </a:r>
-            <a:r>
-              <a:rPr sz="1400">
-                <a:solidFill>
-                  <a:srgbClr val="FBFCFD"/>
-                </a:solidFill>
-              </a:rPr>
-              <a:t> (Perez), </a:t>
+              <a:t>aoi</a:t>
             </a:r>
             <a:r>
               <a:rPr sz="1300">
                 <a:solidFill>
+                  <a:srgbClr val="FBFCFD"/>
+                </a:solidFill>
+              </a:rPr>
+              <a:t>, </a:t>
+            </a:r>
+            <a:r>
+              <a:rPr sz="1200">
+                <a:solidFill>
                   <a:srgbClr val="7FDBFF"/>
                 </a:solidFill>
                 <a:latin typeface="Consolas"/>
               </a:rPr>
-              <a:t>aoi</a:t>
-            </a:r>
-            <a:r>
-              <a:rPr sz="1400">
-                <a:solidFill>
-                  <a:srgbClr val="FBFCFD"/>
-                </a:solidFill>
-              </a:rPr>
-              <a:t>, </a:t>
+              <a:t>get_extra_radiation</a:t>
             </a:r>
             <a:r>
               <a:rPr sz="1300">
-                <a:solidFill>
-                  <a:srgbClr val="7FDBFF"/>
-                </a:solidFill>
-                <a:latin typeface="Consolas"/>
-              </a:rPr>
-              <a:t>get_extra_radiation</a:t>
-            </a:r>
-            <a:r>
-              <a:rPr sz="1400">
                 <a:solidFill>
                   <a:srgbClr val="FBFCFD"/>
                 </a:solidFill>
@@ -20658,11 +20625,11 @@
           <a:p>
             <a:pPr algn="l">
               <a:lnSpc>
-                <a:spcPct val="106000"/>
+                <a:spcPct val="105000"/>
               </a:lnSpc>
             </a:pPr>
             <a:r>
-              <a:rPr sz="1400">
+              <a:rPr sz="1300">
                 <a:solidFill>
                   <a:srgbClr val="FBFCFD"/>
                 </a:solidFill>
@@ -20670,48 +20637,48 @@
               <a:t>• </a:t>
             </a:r>
             <a:r>
+              <a:rPr sz="1200">
+                <a:solidFill>
+                  <a:srgbClr val="7FDBFF"/>
+                </a:solidFill>
+                <a:latin typeface="Consolas"/>
+              </a:rPr>
+              <a:t>iam.physical</a:t>
+            </a:r>
+            <a:r>
               <a:rPr sz="1300">
                 <a:solidFill>
+                  <a:srgbClr val="FBFCFD"/>
+                </a:solidFill>
+              </a:rPr>
+              <a:t> + </a:t>
+            </a:r>
+            <a:r>
+              <a:rPr sz="1200">
+                <a:solidFill>
                   <a:srgbClr val="7FDBFF"/>
                 </a:solidFill>
                 <a:latin typeface="Consolas"/>
               </a:rPr>
-              <a:t>iam.physical</a:t>
-            </a:r>
-            <a:r>
-              <a:rPr sz="1400">
-                <a:solidFill>
-                  <a:srgbClr val="FBFCFD"/>
-                </a:solidFill>
-              </a:rPr>
-              <a:t> + </a:t>
+              <a:t>iam.marion_diffuse</a:t>
             </a:r>
             <a:r>
               <a:rPr sz="1300">
                 <a:solidFill>
-                  <a:srgbClr val="7FDBFF"/>
-                </a:solidFill>
-                <a:latin typeface="Consolas"/>
-              </a:rPr>
-              <a:t>iam.marion_diffuse</a:t>
-            </a:r>
-            <a:r>
-              <a:rPr sz="1400">
-                <a:solidFill>
-                  <a:srgbClr val="FBFCFD"/>
-                </a:solidFill>
-              </a:rPr>
-              <a:t> (IAM directo y difuso).</a:t>
+                  <a:srgbClr val="FBFCFD"/>
+                </a:solidFill>
+              </a:rPr>
+              <a:t> (directo y difuso).</a:t>
             </a:r>
           </a:p>
           <a:p>
             <a:pPr algn="l">
               <a:lnSpc>
-                <a:spcPct val="106000"/>
+                <a:spcPct val="105000"/>
               </a:lnSpc>
             </a:pPr>
             <a:r>
-              <a:rPr sz="1400">
+              <a:rPr sz="1300">
                 <a:solidFill>
                   <a:srgbClr val="FBFCFD"/>
                 </a:solidFill>
@@ -20719,48 +20686,48 @@
               <a:t>• </a:t>
             </a:r>
             <a:r>
+              <a:rPr sz="1200">
+                <a:solidFill>
+                  <a:srgbClr val="7FDBFF"/>
+                </a:solidFill>
+                <a:latin typeface="Consolas"/>
+              </a:rPr>
+              <a:t>spectral_factor_firstsolar</a:t>
+            </a:r>
+            <a:r>
               <a:rPr sz="1300">
                 <a:solidFill>
+                  <a:srgbClr val="FBFCFD"/>
+                </a:solidFill>
+              </a:rPr>
+              <a:t> + </a:t>
+            </a:r>
+            <a:r>
+              <a:rPr sz="1200">
+                <a:solidFill>
                   <a:srgbClr val="7FDBFF"/>
                 </a:solidFill>
                 <a:latin typeface="Consolas"/>
               </a:rPr>
-              <a:t>spectrum.spectral_factor_firstsolar</a:t>
-            </a:r>
-            <a:r>
-              <a:rPr sz="1400">
-                <a:solidFill>
-                  <a:srgbClr val="FBFCFD"/>
-                </a:solidFill>
-              </a:rPr>
-              <a:t>, </a:t>
+              <a:t>gueymard94_pw</a:t>
             </a:r>
             <a:r>
               <a:rPr sz="1300">
                 <a:solidFill>
-                  <a:srgbClr val="7FDBFF"/>
-                </a:solidFill>
-                <a:latin typeface="Consolas"/>
-              </a:rPr>
-              <a:t>atmosphere.gueymard94_pw</a:t>
-            </a:r>
-            <a:r>
-              <a:rPr sz="1400">
-                <a:solidFill>
-                  <a:srgbClr val="FBFCFD"/>
-                </a:solidFill>
-              </a:rPr>
-              <a:t> + airmass.</a:t>
+                  <a:srgbClr val="FBFCFD"/>
+                </a:solidFill>
+              </a:rPr>
+              <a:t> (espectral).</a:t>
             </a:r>
           </a:p>
           <a:p>
             <a:pPr algn="l">
               <a:lnSpc>
-                <a:spcPct val="106000"/>
+                <a:spcPct val="105000"/>
               </a:lnSpc>
             </a:pPr>
             <a:r>
-              <a:rPr sz="1400">
+              <a:rPr sz="1300">
                 <a:solidFill>
                   <a:srgbClr val="FBFCFD"/>
                 </a:solidFill>
@@ -20768,31 +20735,31 @@
               <a:t>• </a:t>
             </a:r>
             <a:r>
+              <a:rPr sz="1200">
+                <a:solidFill>
+                  <a:srgbClr val="7FDBFF"/>
+                </a:solidFill>
+                <a:latin typeface="Consolas"/>
+              </a:rPr>
+              <a:t>temperature.sapm_cell</a:t>
+            </a:r>
+            <a:r>
               <a:rPr sz="1300">
                 <a:solidFill>
-                  <a:srgbClr val="7FDBFF"/>
-                </a:solidFill>
-                <a:latin typeface="Consolas"/>
-              </a:rPr>
-              <a:t>temperature.sapm_cell</a:t>
-            </a:r>
-            <a:r>
-              <a:rPr sz="1400">
-                <a:solidFill>
-                  <a:srgbClr val="FBFCFD"/>
-                </a:solidFill>
-              </a:rPr>
-              <a:t> (modelo térmico Sandia).</a:t>
+                  <a:srgbClr val="FBFCFD"/>
+                </a:solidFill>
+              </a:rPr>
+              <a:t> (térmico Sandia).</a:t>
             </a:r>
           </a:p>
           <a:p>
             <a:pPr algn="l">
               <a:lnSpc>
-                <a:spcPct val="106000"/>
+                <a:spcPct val="105000"/>
               </a:lnSpc>
             </a:pPr>
             <a:r>
-              <a:rPr sz="1400">
+              <a:rPr sz="1300">
                 <a:solidFill>
                   <a:srgbClr val="FBFCFD"/>
                 </a:solidFill>
@@ -20800,50 +20767,50 @@
               <a:t>• </a:t>
             </a:r>
             <a:r>
+              <a:rPr sz="1200">
+                <a:solidFill>
+                  <a:srgbClr val="7FDBFF"/>
+                </a:solidFill>
+                <a:latin typeface="Consolas"/>
+              </a:rPr>
+              <a:t>calcparams_desoto</a:t>
+            </a:r>
+            <a:r>
               <a:rPr sz="1300">
                 <a:solidFill>
+                  <a:srgbClr val="FBFCFD"/>
+                </a:solidFill>
+              </a:rPr>
+              <a:t>, </a:t>
+            </a:r>
+            <a:r>
+              <a:rPr sz="1200">
+                <a:solidFill>
                   <a:srgbClr val="7FDBFF"/>
                 </a:solidFill>
                 <a:latin typeface="Consolas"/>
               </a:rPr>
-              <a:t>pvsystem.calcparams_desoto</a:t>
-            </a:r>
-            <a:r>
-              <a:rPr sz="1400">
-                <a:solidFill>
-                  <a:srgbClr val="FBFCFD"/>
-                </a:solidFill>
-              </a:rPr>
-              <a:t> · </a:t>
+              <a:t>singlediode</a:t>
             </a:r>
             <a:r>
               <a:rPr sz="1300">
                 <a:solidFill>
+                  <a:srgbClr val="FBFCFD"/>
+                </a:solidFill>
+              </a:rPr>
+              <a:t>, </a:t>
+            </a:r>
+            <a:r>
+              <a:rPr sz="1200">
+                <a:solidFill>
                   <a:srgbClr val="7FDBFF"/>
                 </a:solidFill>
                 <a:latin typeface="Consolas"/>
               </a:rPr>
-              <a:t>singlediode</a:t>
-            </a:r>
-            <a:r>
-              <a:rPr sz="1400">
-                <a:solidFill>
-                  <a:srgbClr val="FBFCFD"/>
-                </a:solidFill>
-              </a:rPr>
-              <a:t> · </a:t>
+              <a:t>i_from_v</a:t>
             </a:r>
             <a:r>
               <a:rPr sz="1300">
-                <a:solidFill>
-                  <a:srgbClr val="7FDBFF"/>
-                </a:solidFill>
-                <a:latin typeface="Consolas"/>
-              </a:rPr>
-              <a:t>i_from_v</a:t>
-            </a:r>
-            <a:r>
-              <a:rPr sz="1400">
                 <a:solidFill>
                   <a:srgbClr val="FBFCFD"/>
                 </a:solidFill>
@@ -20854,11 +20821,11 @@
           <a:p>
             <a:pPr algn="l">
               <a:lnSpc>
-                <a:spcPct val="106000"/>
+                <a:spcPct val="105000"/>
               </a:lnSpc>
             </a:pPr>
             <a:r>
-              <a:rPr sz="1400">
+              <a:rPr sz="1300">
                 <a:solidFill>
                   <a:srgbClr val="FBFCFD"/>
                 </a:solidFill>
@@ -20866,33 +20833,33 @@
               <a:t>• </a:t>
             </a:r>
             <a:r>
+              <a:rPr sz="1200">
+                <a:solidFill>
+                  <a:srgbClr val="7FDBFF"/>
+                </a:solidFill>
+                <a:latin typeface="Consolas"/>
+              </a:rPr>
+              <a:t>iotools.get_pvgis_tmy</a:t>
+            </a:r>
+            <a:r>
               <a:rPr sz="1300">
                 <a:solidFill>
+                  <a:srgbClr val="FBFCFD"/>
+                </a:solidFill>
+              </a:rPr>
+              <a:t>, </a:t>
+            </a:r>
+            <a:r>
+              <a:rPr sz="1200">
+                <a:solidFill>
                   <a:srgbClr val="7FDBFF"/>
                 </a:solidFill>
                 <a:latin typeface="Consolas"/>
               </a:rPr>
-              <a:t>iotools.get_pvgis_tmy</a:t>
-            </a:r>
-            <a:r>
-              <a:rPr sz="1400">
-                <a:solidFill>
-                  <a:srgbClr val="FBFCFD"/>
-                </a:solidFill>
-              </a:rPr>
-              <a:t> · </a:t>
+              <a:t>location.Location</a:t>
             </a:r>
             <a:r>
               <a:rPr sz="1300">
-                <a:solidFill>
-                  <a:srgbClr val="7FDBFF"/>
-                </a:solidFill>
-                <a:latin typeface="Consolas"/>
-              </a:rPr>
-              <a:t>location.Location</a:t>
-            </a:r>
-            <a:r>
-              <a:rPr sz="1400">
                 <a:solidFill>
                   <a:srgbClr val="FBFCFD"/>
                 </a:solidFill>
@@ -20911,7 +20878,7 @@
         <p:spPr>
           <a:xfrm>
             <a:off x="6233007" y="1188720"/>
-            <a:ext cx="5592927" cy="2395728"/>
+            <a:ext cx="5592927" cy="2194560"/>
           </a:xfrm>
           <a:prstGeom prst="rect">
             <a:avLst/>
@@ -20956,7 +20923,7 @@
         <p:spPr>
           <a:xfrm>
             <a:off x="6233007" y="1188720"/>
-            <a:ext cx="73152" cy="2395728"/>
+            <a:ext cx="73152" cy="2194560"/>
           </a:xfrm>
           <a:prstGeom prst="rect">
             <a:avLst/>
@@ -21033,7 +21000,7 @@
         <p:spPr>
           <a:xfrm>
             <a:off x="6434175" y="1828800"/>
-            <a:ext cx="5190591" cy="1591056"/>
+            <a:ext cx="5190591" cy="1389888"/>
           </a:xfrm>
           <a:prstGeom prst="rect">
             <a:avLst/>
@@ -21048,11 +21015,11 @@
           <a:p>
             <a:pPr algn="l">
               <a:lnSpc>
-                <a:spcPct val="106000"/>
+                <a:spcPct val="105000"/>
               </a:lnSpc>
             </a:pPr>
             <a:r>
-              <a:rPr sz="1400">
+              <a:rPr sz="1300">
                 <a:solidFill>
                   <a:srgbClr val="FBFCFD"/>
                 </a:solidFill>
@@ -21060,7 +21027,7 @@
               <a:t>• </a:t>
             </a:r>
             <a:r>
-              <a:rPr sz="1400" b="1">
+              <a:rPr sz="1300" b="1">
                 <a:solidFill>
                   <a:srgbClr val="FBFCFD"/>
                 </a:solidFill>
@@ -21068,7 +21035,7 @@
               <a:t>Matplotlib</a:t>
             </a:r>
             <a:r>
-              <a:rPr sz="1400">
+              <a:rPr sz="1300">
                 <a:solidFill>
                   <a:srgbClr val="FBFCFD"/>
                 </a:solidFill>
@@ -21076,16 +21043,16 @@
               <a:t> — gráficos (modo oscuro, </a:t>
             </a:r>
             <a:r>
+              <a:rPr sz="1200">
+                <a:solidFill>
+                  <a:srgbClr val="7FDBFF"/>
+                </a:solidFill>
+                <a:latin typeface="Consolas"/>
+              </a:rPr>
+              <a:t>mathtext</a:t>
+            </a:r>
+            <a:r>
               <a:rPr sz="1300">
-                <a:solidFill>
-                  <a:srgbClr val="7FDBFF"/>
-                </a:solidFill>
-                <a:latin typeface="Consolas"/>
-              </a:rPr>
-              <a:t>mathtext</a:t>
-            </a:r>
-            <a:r>
-              <a:rPr sz="1400">
                 <a:solidFill>
                   <a:srgbClr val="FBFCFD"/>
                 </a:solidFill>
@@ -21096,11 +21063,11 @@
           <a:p>
             <a:pPr algn="l">
               <a:lnSpc>
-                <a:spcPct val="106000"/>
+                <a:spcPct val="105000"/>
               </a:lnSpc>
             </a:pPr>
             <a:r>
-              <a:rPr sz="1400">
+              <a:rPr sz="1300">
                 <a:solidFill>
                   <a:srgbClr val="FBFCFD"/>
                 </a:solidFill>
@@ -21108,7 +21075,7 @@
               <a:t>• </a:t>
             </a:r>
             <a:r>
-              <a:rPr sz="1400" b="1">
+              <a:rPr sz="1300" b="1">
                 <a:solidFill>
                   <a:srgbClr val="FBFCFD"/>
                 </a:solidFill>
@@ -21116,7 +21083,7 @@
               <a:t>python-pptx</a:t>
             </a:r>
             <a:r>
-              <a:rPr sz="1400">
+              <a:rPr sz="1300">
                 <a:solidFill>
                   <a:srgbClr val="FBFCFD"/>
                 </a:solidFill>
@@ -21127,11 +21094,11 @@
           <a:p>
             <a:pPr algn="l">
               <a:lnSpc>
-                <a:spcPct val="106000"/>
+                <a:spcPct val="105000"/>
               </a:lnSpc>
             </a:pPr>
             <a:r>
-              <a:rPr sz="1400">
+              <a:rPr sz="1300">
                 <a:solidFill>
                   <a:srgbClr val="FBFCFD"/>
                 </a:solidFill>
@@ -21139,7 +21106,7 @@
               <a:t>• </a:t>
             </a:r>
             <a:r>
-              <a:rPr sz="1400" b="1">
+              <a:rPr sz="1300" b="1">
                 <a:solidFill>
                   <a:srgbClr val="FBFCFD"/>
                 </a:solidFill>
@@ -21147,7 +21114,7 @@
               <a:t>Pillow (PIL)</a:t>
             </a:r>
             <a:r>
-              <a:rPr sz="1400">
+              <a:rPr sz="1300">
                 <a:solidFill>
                   <a:srgbClr val="FBFCFD"/>
                 </a:solidFill>
@@ -21158,11 +21125,11 @@
           <a:p>
             <a:pPr algn="l">
               <a:lnSpc>
-                <a:spcPct val="106000"/>
+                <a:spcPct val="105000"/>
               </a:lnSpc>
             </a:pPr>
             <a:r>
-              <a:rPr sz="1400">
+              <a:rPr sz="1300">
                 <a:solidFill>
                   <a:srgbClr val="FBFCFD"/>
                 </a:solidFill>
@@ -21170,7 +21137,7 @@
               <a:t>• </a:t>
             </a:r>
             <a:r>
-              <a:rPr sz="1400" b="1">
+              <a:rPr sz="1300" b="1">
                 <a:solidFill>
                   <a:srgbClr val="FBFCFD"/>
                 </a:solidFill>
@@ -21178,7 +21145,7 @@
               <a:t>pywin32</a:t>
             </a:r>
             <a:r>
-              <a:rPr sz="1400">
+              <a:rPr sz="1300">
                 <a:solidFill>
                   <a:srgbClr val="FBFCFD"/>
                 </a:solidFill>
@@ -21186,16 +21153,16 @@
               <a:t> (</a:t>
             </a:r>
             <a:r>
+              <a:rPr sz="1200">
+                <a:solidFill>
+                  <a:srgbClr val="7FDBFF"/>
+                </a:solidFill>
+                <a:latin typeface="Consolas"/>
+              </a:rPr>
+              <a:t>win32com</a:t>
+            </a:r>
+            <a:r>
               <a:rPr sz="1300">
-                <a:solidFill>
-                  <a:srgbClr val="7FDBFF"/>
-                </a:solidFill>
-                <a:latin typeface="Consolas"/>
-              </a:rPr>
-              <a:t>win32com</a:t>
-            </a:r>
-            <a:r>
-              <a:rPr sz="1400">
                 <a:solidFill>
                   <a:srgbClr val="FBFCFD"/>
                 </a:solidFill>
@@ -21213,8 +21180,8 @@
         </p:nvSpPr>
         <p:spPr>
           <a:xfrm>
-            <a:off x="6233007" y="3785616"/>
-            <a:ext cx="5592927" cy="2395728"/>
+            <a:off x="6233007" y="3584448"/>
+            <a:ext cx="5592927" cy="2724912"/>
           </a:xfrm>
           <a:prstGeom prst="rect">
             <a:avLst/>
@@ -21258,8 +21225,8 @@
         </p:nvSpPr>
         <p:spPr>
           <a:xfrm>
-            <a:off x="6233007" y="3785616"/>
-            <a:ext cx="73152" cy="2395728"/>
+            <a:off x="6233007" y="3584448"/>
+            <a:ext cx="73152" cy="2724912"/>
           </a:xfrm>
           <a:prstGeom prst="rect">
             <a:avLst/>
@@ -21301,7 +21268,7 @@
         </p:nvSpPr>
         <p:spPr>
           <a:xfrm>
-            <a:off x="6397599" y="3877056"/>
+            <a:off x="6397599" y="3675888"/>
             <a:ext cx="5318607" cy="411480"/>
           </a:xfrm>
           <a:prstGeom prst="rect">
@@ -21335,8 +21302,8 @@
         </p:nvSpPr>
         <p:spPr>
           <a:xfrm>
-            <a:off x="6434175" y="4425696"/>
-            <a:ext cx="5190591" cy="1591056"/>
+            <a:off x="6434175" y="4224528"/>
+            <a:ext cx="5190591" cy="1920240"/>
           </a:xfrm>
           <a:prstGeom prst="rect">
             <a:avLst/>
@@ -21351,11 +21318,11 @@
           <a:p>
             <a:pPr algn="l">
               <a:lnSpc>
-                <a:spcPct val="106000"/>
+                <a:spcPct val="105000"/>
               </a:lnSpc>
             </a:pPr>
             <a:r>
-              <a:rPr sz="1400">
+              <a:rPr sz="1300">
                 <a:solidFill>
                   <a:srgbClr val="FBFCFD"/>
                 </a:solidFill>
@@ -21363,7 +21330,7 @@
               <a:t>• </a:t>
             </a:r>
             <a:r>
-              <a:rPr sz="1400" b="1">
+              <a:rPr sz="1300" b="1">
                 <a:solidFill>
                   <a:srgbClr val="FBFCFD"/>
                 </a:solidFill>
@@ -21371,7 +21338,7 @@
               <a:t>python-dateutil</a:t>
             </a:r>
             <a:r>
-              <a:rPr sz="1400">
+              <a:rPr sz="1300">
                 <a:solidFill>
                   <a:srgbClr val="FBFCFD"/>
                 </a:solidFill>
@@ -21379,16 +21346,16 @@
               <a:t> (</a:t>
             </a:r>
             <a:r>
+              <a:rPr sz="1200">
+                <a:solidFill>
+                  <a:srgbClr val="7FDBFF"/>
+                </a:solidFill>
+                <a:latin typeface="Consolas"/>
+              </a:rPr>
+              <a:t>relativedelta</a:t>
+            </a:r>
+            <a:r>
               <a:rPr sz="1300">
-                <a:solidFill>
-                  <a:srgbClr val="7FDBFF"/>
-                </a:solidFill>
-                <a:latin typeface="Consolas"/>
-              </a:rPr>
-              <a:t>relativedelta</a:t>
-            </a:r>
-            <a:r>
-              <a:rPr sz="1400">
                 <a:solidFill>
                   <a:srgbClr val="FBFCFD"/>
                 </a:solidFill>
@@ -21399,11 +21366,11 @@
           <a:p>
             <a:pPr algn="l">
               <a:lnSpc>
-                <a:spcPct val="106000"/>
+                <a:spcPct val="105000"/>
               </a:lnSpc>
             </a:pPr>
             <a:r>
-              <a:rPr sz="1400">
+              <a:rPr sz="1300">
                 <a:solidFill>
                   <a:srgbClr val="FBFCFD"/>
                 </a:solidFill>
@@ -21411,7 +21378,7 @@
               <a:t>• </a:t>
             </a:r>
             <a:r>
-              <a:rPr sz="1400" b="1">
+              <a:rPr sz="1300" b="1">
                 <a:solidFill>
                   <a:srgbClr val="FBFCFD"/>
                 </a:solidFill>
@@ -21419,7 +21386,7 @@
               <a:t>stdlib:</a:t>
             </a:r>
             <a:r>
-              <a:rPr sz="1400">
+              <a:rPr sz="1300">
                 <a:solidFill>
                   <a:srgbClr val="FBFCFD"/>
                 </a:solidFill>
@@ -21427,16 +21394,33 @@
               <a:t> </a:t>
             </a:r>
             <a:r>
+              <a:rPr sz="1200">
+                <a:solidFill>
+                  <a:srgbClr val="7FDBFF"/>
+                </a:solidFill>
+                <a:latin typeface="Consolas"/>
+              </a:rPr>
+              <a:t>csv</a:t>
+            </a:r>
+            <a:r>
               <a:rPr sz="1300">
                 <a:solidFill>
+                  <a:srgbClr val="FBFCFD"/>
+                </a:solidFill>
+              </a:rPr>
+              <a:t>, </a:t>
+            </a:r>
+            <a:r>
+              <a:rPr sz="1200">
+                <a:solidFill>
                   <a:srgbClr val="7FDBFF"/>
                 </a:solidFill>
                 <a:latin typeface="Consolas"/>
               </a:rPr>
-              <a:t>csv</a:t>
-            </a:r>
-            <a:r>
-              <a:rPr sz="1400">
+              <a:t>json</a:t>
+            </a:r>
+            <a:r>
+              <a:rPr sz="1300">
                 <a:solidFill>
                   <a:srgbClr val="FBFCFD"/>
                 </a:solidFill>
@@ -21444,16 +21428,33 @@
               <a:t>, </a:t>
             </a:r>
             <a:r>
+              <a:rPr sz="1200">
+                <a:solidFill>
+                  <a:srgbClr val="7FDBFF"/>
+                </a:solidFill>
+                <a:latin typeface="Consolas"/>
+              </a:rPr>
+              <a:t>os</a:t>
+            </a:r>
+            <a:r>
               <a:rPr sz="1300">
                 <a:solidFill>
+                  <a:srgbClr val="FBFCFD"/>
+                </a:solidFill>
+              </a:rPr>
+              <a:t>, </a:t>
+            </a:r>
+            <a:r>
+              <a:rPr sz="1200">
+                <a:solidFill>
                   <a:srgbClr val="7FDBFF"/>
                 </a:solidFill>
                 <a:latin typeface="Consolas"/>
               </a:rPr>
-              <a:t>json</a:t>
-            </a:r>
-            <a:r>
-              <a:rPr sz="1400">
+              <a:t>re</a:t>
+            </a:r>
+            <a:r>
+              <a:rPr sz="1300">
                 <a:solidFill>
                   <a:srgbClr val="FBFCFD"/>
                 </a:solidFill>
@@ -21461,16 +21462,33 @@
               <a:t>, </a:t>
             </a:r>
             <a:r>
+              <a:rPr sz="1200">
+                <a:solidFill>
+                  <a:srgbClr val="7FDBFF"/>
+                </a:solidFill>
+                <a:latin typeface="Consolas"/>
+              </a:rPr>
+              <a:t>datetime</a:t>
+            </a:r>
+            <a:r>
               <a:rPr sz="1300">
                 <a:solidFill>
+                  <a:srgbClr val="FBFCFD"/>
+                </a:solidFill>
+              </a:rPr>
+              <a:t>, </a:t>
+            </a:r>
+            <a:r>
+              <a:rPr sz="1200">
+                <a:solidFill>
                   <a:srgbClr val="7FDBFF"/>
                 </a:solidFill>
                 <a:latin typeface="Consolas"/>
               </a:rPr>
-              <a:t>os</a:t>
-            </a:r>
-            <a:r>
-              <a:rPr sz="1400">
+              <a:t>hashlib</a:t>
+            </a:r>
+            <a:r>
+              <a:rPr sz="1300">
                 <a:solidFill>
                   <a:srgbClr val="FBFCFD"/>
                 </a:solidFill>
@@ -21478,67 +21496,16 @@
               <a:t>, </a:t>
             </a:r>
             <a:r>
+              <a:rPr sz="1200">
+                <a:solidFill>
+                  <a:srgbClr val="7FDBFF"/>
+                </a:solidFill>
+                <a:latin typeface="Consolas"/>
+              </a:rPr>
+              <a:t>math</a:t>
+            </a:r>
+            <a:r>
               <a:rPr sz="1300">
-                <a:solidFill>
-                  <a:srgbClr val="7FDBFF"/>
-                </a:solidFill>
-                <a:latin typeface="Consolas"/>
-              </a:rPr>
-              <a:t>re</a:t>
-            </a:r>
-            <a:r>
-              <a:rPr sz="1400">
-                <a:solidFill>
-                  <a:srgbClr val="FBFCFD"/>
-                </a:solidFill>
-              </a:rPr>
-              <a:t>, </a:t>
-            </a:r>
-            <a:r>
-              <a:rPr sz="1300">
-                <a:solidFill>
-                  <a:srgbClr val="7FDBFF"/>
-                </a:solidFill>
-                <a:latin typeface="Consolas"/>
-              </a:rPr>
-              <a:t>datetime</a:t>
-            </a:r>
-            <a:r>
-              <a:rPr sz="1400">
-                <a:solidFill>
-                  <a:srgbClr val="FBFCFD"/>
-                </a:solidFill>
-              </a:rPr>
-              <a:t>, </a:t>
-            </a:r>
-            <a:r>
-              <a:rPr sz="1300">
-                <a:solidFill>
-                  <a:srgbClr val="7FDBFF"/>
-                </a:solidFill>
-                <a:latin typeface="Consolas"/>
-              </a:rPr>
-              <a:t>hashlib</a:t>
-            </a:r>
-            <a:r>
-              <a:rPr sz="1400">
-                <a:solidFill>
-                  <a:srgbClr val="FBFCFD"/>
-                </a:solidFill>
-              </a:rPr>
-              <a:t>, </a:t>
-            </a:r>
-            <a:r>
-              <a:rPr sz="1300">
-                <a:solidFill>
-                  <a:srgbClr val="7FDBFF"/>
-                </a:solidFill>
-                <a:latin typeface="Consolas"/>
-              </a:rPr>
-              <a:t>math</a:t>
-            </a:r>
-            <a:r>
-              <a:rPr sz="1400">
                 <a:solidFill>
                   <a:srgbClr val="FBFCFD"/>
                 </a:solidFill>
@@ -21549,11 +21516,11 @@
           <a:p>
             <a:pPr algn="l">
               <a:lnSpc>
-                <a:spcPct val="106000"/>
+                <a:spcPct val="105000"/>
               </a:lnSpc>
             </a:pPr>
             <a:r>
-              <a:rPr sz="1400">
+              <a:rPr sz="1300">
                 <a:solidFill>
                   <a:srgbClr val="FBFCFD"/>
                 </a:solidFill>
@@ -21561,7 +21528,7 @@
               <a:t>• </a:t>
             </a:r>
             <a:r>
-              <a:rPr sz="1400" b="1">
+              <a:rPr sz="1300" b="1">
                 <a:solidFill>
                   <a:srgbClr val="FBFCFD"/>
                 </a:solidFill>
@@ -21569,7 +21536,7 @@
               <a:t>Dataset NREL Cocoa</a:t>
             </a:r>
             <a:r>
-              <a:rPr sz="1400">
+              <a:rPr sz="1300">
                 <a:solidFill>
                   <a:srgbClr val="FBFCFD"/>
                 </a:solidFill>
@@ -21580,11 +21547,11 @@
           <a:p>
             <a:pPr algn="l">
               <a:lnSpc>
-                <a:spcPct val="106000"/>
+                <a:spcPct val="105000"/>
               </a:lnSpc>
             </a:pPr>
             <a:r>
-              <a:rPr sz="1400">
+              <a:rPr sz="1300">
                 <a:solidFill>
                   <a:srgbClr val="FBFCFD"/>
                 </a:solidFill>
@@ -21592,7 +21559,7 @@
               <a:t>• </a:t>
             </a:r>
             <a:r>
-              <a:rPr sz="1400" b="1">
+              <a:rPr sz="1300" b="1">
                 <a:solidFill>
                   <a:srgbClr val="FBFCFD"/>
                 </a:solidFill>
@@ -21600,7 +21567,7 @@
               <a:t>PVGIS TMY</a:t>
             </a:r>
             <a:r>
-              <a:rPr sz="1400">
+              <a:rPr sz="1300">
                 <a:solidFill>
                   <a:srgbClr val="FBFCFD"/>
                 </a:solidFill>
@@ -34011,7 +33978,7 @@
                   <a:srgbClr val="FBFCFD"/>
                 </a:solidFill>
               </a:rPr>
-              <a:t> IAM físico de Snell-Bouguer y factor espectral por masa de aire [King et al., 2004] — ejecutados en la Fase 2 sobre la POA. (Anexo II, Lám. 29)</a:t>
+              <a:t> descuentan la luz que se refleja en el vidrio cuando el sol llega muy inclinado (IAM) y la corrigen según el espectro solar; aplicados en la Fase 2 — fórmulas y parámetros en (Anexo II, Lám. 29).</a:t>
             </a:r>
           </a:p>
         </p:txBody>
@@ -34975,7 +34942,7 @@
         <p:spPr>
           <a:xfrm>
             <a:off x="365760" y="2788920"/>
-            <a:ext cx="5592927" cy="3383280"/>
+            <a:ext cx="5592927" cy="3566160"/>
           </a:xfrm>
           <a:prstGeom prst="rect">
             <a:avLst/>
@@ -35020,7 +34987,7 @@
         <p:spPr>
           <a:xfrm>
             <a:off x="365760" y="2788920"/>
-            <a:ext cx="73152" cy="3383280"/>
+            <a:ext cx="73152" cy="3566160"/>
           </a:xfrm>
           <a:prstGeom prst="rect">
             <a:avLst/>
@@ -35097,7 +35064,7 @@
         <p:spPr>
           <a:xfrm>
             <a:off x="566928" y="3429000"/>
-            <a:ext cx="5190591" cy="2578608"/>
+            <a:ext cx="5190591" cy="2761488"/>
           </a:xfrm>
           <a:prstGeom prst="rect">
             <a:avLst/>
@@ -35116,7 +35083,7 @@
               </a:lnSpc>
             </a:pPr>
             <a:r>
-              <a:rPr sz="1650">
+              <a:rPr sz="1550">
                 <a:solidFill>
                   <a:srgbClr val="FBFCFD"/>
                 </a:solidFill>
@@ -35124,7 +35091,7 @@
               <a:t>• </a:t>
             </a:r>
             <a:r>
-              <a:rPr sz="1650" b="1">
+              <a:rPr sz="1550" b="1">
                 <a:solidFill>
                   <a:srgbClr val="FBFCFD"/>
                 </a:solidFill>
@@ -35132,7 +35099,7 @@
               <a:t>Recurso REAL (no escalado):</a:t>
             </a:r>
             <a:r>
-              <a:rPr sz="1650">
+              <a:rPr sz="1550">
                 <a:solidFill>
                   <a:srgbClr val="FBFCFD"/>
                 </a:solidFill>
@@ -35154,7 +35121,7 @@
               </a:lnSpc>
             </a:pPr>
             <a:r>
-              <a:rPr sz="1650">
+              <a:rPr sz="1550">
                 <a:solidFill>
                   <a:srgbClr val="FBFCFD"/>
                 </a:solidFill>
@@ -35176,7 +35143,7 @@
               </a:lnSpc>
             </a:pPr>
             <a:r>
-              <a:rPr sz="1650">
+              <a:rPr sz="1550">
                 <a:solidFill>
                   <a:srgbClr val="FBFCFD"/>
                 </a:solidFill>
@@ -35184,7 +35151,7 @@
               <a:t>• 33 kWh/kWp × 100,000 kWp = </a:t>
             </a:r>
             <a:r>
-              <a:rPr sz="1650" b="1">
+              <a:rPr sz="1550" b="1">
                 <a:solidFill>
                   <a:srgbClr val="FBFCFD"/>
                 </a:solidFill>
@@ -35192,7 +35159,7 @@
               <a:t>+3,294 MWh/año</a:t>
             </a:r>
             <a:r>
-              <a:rPr sz="1650">
+              <a:rPr sz="1550">
                 <a:solidFill>
                   <a:srgbClr val="FBFCFD"/>
                 </a:solidFill>
@@ -35214,7 +35181,7 @@
               </a:lnSpc>
             </a:pPr>
             <a:r>
-              <a:rPr sz="1650">
+              <a:rPr sz="1550">
                 <a:solidFill>
                   <a:srgbClr val="FBFCFD"/>
                 </a:solidFill>
@@ -35222,7 +35189,7 @@
               <a:t>• Precio de venta ≈ 45 USD/MWh → </a:t>
             </a:r>
             <a:r>
-              <a:rPr sz="1650" b="1">
+              <a:rPr sz="1550" b="1">
                 <a:solidFill>
                   <a:srgbClr val="FBFCFD"/>
                 </a:solidFill>
@@ -35230,7 +35197,7 @@
               <a:t>+USD 148k/año</a:t>
             </a:r>
             <a:r>
-              <a:rPr sz="1650">
+              <a:rPr sz="1550">
                 <a:solidFill>
                   <a:srgbClr val="FBFCFD"/>
                 </a:solidFill>
@@ -35249,7 +35216,7 @@
         <p:spPr>
           <a:xfrm>
             <a:off x="6233007" y="2788920"/>
-            <a:ext cx="5592927" cy="3383280"/>
+            <a:ext cx="5592927" cy="3566160"/>
           </a:xfrm>
           <a:prstGeom prst="rect">
             <a:avLst/>
@@ -35294,7 +35261,7 @@
         <p:spPr>
           <a:xfrm>
             <a:off x="6233007" y="2788920"/>
-            <a:ext cx="73152" cy="3383280"/>
+            <a:ext cx="73152" cy="3566160"/>
           </a:xfrm>
           <a:prstGeom prst="rect">
             <a:avLst/>
@@ -35371,7 +35338,7 @@
         <p:spPr>
           <a:xfrm>
             <a:off x="6434175" y="3429000"/>
-            <a:ext cx="5190591" cy="2578608"/>
+            <a:ext cx="5190591" cy="2761488"/>
           </a:xfrm>
           <a:prstGeom prst="rect">
             <a:avLst/>
@@ -35390,7 +35357,7 @@
               </a:lnSpc>
             </a:pPr>
             <a:r>
-              <a:rPr sz="1650">
+              <a:rPr sz="1550">
                 <a:solidFill>
                   <a:srgbClr val="FBFCFD"/>
                 </a:solidFill>
@@ -35398,7 +35365,7 @@
               <a:t>• La prima CAPEX de los módulos HIT se </a:t>
             </a:r>
             <a:r>
-              <a:rPr sz="1650" b="1">
+              <a:rPr sz="1550" b="1">
                 <a:solidFill>
                   <a:srgbClr val="FBFCFD"/>
                 </a:solidFill>
@@ -35406,7 +35373,7 @@
               <a:t>amortiza</a:t>
             </a:r>
             <a:r>
-              <a:rPr sz="1650">
+              <a:rPr sz="1550">
                 <a:solidFill>
                   <a:srgbClr val="FBFCFD"/>
                 </a:solidFill>
@@ -35428,7 +35395,7 @@
               </a:lnSpc>
             </a:pPr>
             <a:r>
-              <a:rPr sz="1650">
+              <a:rPr sz="1550">
                 <a:solidFill>
                   <a:srgbClr val="FBFCFD"/>
                 </a:solidFill>
@@ -35436,7 +35403,7 @@
               <a:t>• La ventaja relativa de HIT es </a:t>
             </a:r>
             <a:r>
-              <a:rPr sz="1650" b="1">
+              <a:rPr sz="1550" b="1">
                 <a:solidFill>
                   <a:srgbClr val="FBFCFD"/>
                 </a:solidFill>
@@ -35444,7 +35411,7 @@
               <a:t>menor</a:t>
             </a:r>
             <a:r>
-              <a:rPr sz="1650">
+              <a:rPr sz="1550">
                 <a:solidFill>
                   <a:srgbClr val="FBFCFD"/>
                 </a:solidFill>
@@ -35466,7 +35433,7 @@
               </a:lnSpc>
             </a:pPr>
             <a:r>
-              <a:rPr sz="1650">
+              <a:rPr sz="1550">
                 <a:solidFill>
                   <a:srgbClr val="FBFCFD"/>
                 </a:solidFill>

</xml_diff>